<commit_message>
docs: add cost-of-a-breach ROI slide
Co-Authored-By: Devin AI <158243242+devin-ai-integration[bot]@users.noreply.github.com>
</commit_message>
<xml_diff>
--- a/demo-materials/UPS-Devin-Summary-and-ROI.pptx
+++ b/demo-materials/UPS-Devin-Summary-and-ROI.pptx
@@ -13,6 +13,7 @@
     <p:sldId id="261" r:id="rId12"/>
     <p:sldId id="262" r:id="rId13"/>
     <p:sldId id="263" r:id="rId14"/>
+    <p:sldId id="264" r:id="rId15"/>
   </p:sldIdLst>
   <p:sldSz cx="12191695" cy="6858000" type="screen4x3"/>
   <p:notesSz cx="6858000" cy="9144000"/>
@@ -9382,7 +9383,7 @@
                 </a:solidFill>
                 <a:latin typeface="Calibri"/>
               </a:rPr>
-              <a:t>  Industry-average breach cost ~$4.9M (IBM 2024). One avoided incident in Track/Ship dwarfs the labor savings; SLA credits are UPS-specific.</a:t>
+              <a:t>  US-average breach cost $9.4M (IBM 2024). Expected loss from the unpatched estate: ~$0.5–2M per year — see next slide.</a:t>
             </a:r>
           </a:p>
           <a:p>
@@ -9734,7 +9735,7 @@
                 </a:solidFill>
                 <a:latin typeface="Calibri"/>
               </a:rPr>
-              <a:t>Next steps</a:t>
+              <a:t>ROI — the cost of a breach</a:t>
             </a:r>
           </a:p>
         </p:txBody>
@@ -9769,7 +9770,7 @@
                 </a:solidFill>
                 <a:latin typeface="Calibri"/>
               </a:rPr>
-              <a:t>From one proven module to a portfolio program</a:t>
+              <a:t>Expected-loss view of running Spring 5.3 / Boot 2.7 / Java 8 past end of support</a:t>
             </a:r>
           </a:p>
         </p:txBody>
@@ -9809,16 +9810,739 @@
           </a:p>
         </p:txBody>
       </p:sp>
-      <p:sp>
-        <p:nvSpPr>
-          <p:cNvPr id="7" name="Rectangle 6"/>
+      <p:graphicFrame>
+        <p:nvGraphicFramePr>
+          <p:cNvPr id="7" name="Table 6"/>
+          <p:cNvGraphicFramePr>
+            <a:graphicFrameLocks noGrp="1"/>
+          </p:cNvGraphicFramePr>
+          <p:nvPr/>
+        </p:nvGraphicFramePr>
+        <p:xfrm>
+          <a:off x="548640" y="1371600"/>
+          <a:ext cx="6949440" cy="1920240"/>
+        </p:xfrm>
+        <a:graphic>
+          <a:graphicData uri="http://schemas.openxmlformats.org/drawingml/2006/table">
+            <a:tbl>
+              <a:tblPr firstRow="1" bandRow="1">
+                <a:tableStyleId>{5C22544A-7EE6-4342-B048-85BDC9FD1C3A}</a:tableStyleId>
+              </a:tblPr>
+              <a:tblGrid>
+                <a:gridCol w="4206240"/>
+                <a:gridCol w="2743200"/>
+              </a:tblGrid>
+              <a:tr h="384048">
+                <a:tc>
+                  <a:txBody>
+                    <a:bodyPr wrap="square"/>
+                    <a:lstStyle/>
+                    <a:p>
+                      <a:r>
+                        <a:rPr sz="1400" b="1">
+                          <a:solidFill>
+                            <a:srgbClr val="FFFFFF"/>
+                          </a:solidFill>
+                          <a:latin typeface="Calibri"/>
+                        </a:rPr>
+                        <a:t>Benchmark (IBM Cost of a Data Breach 2024)</a:t>
+                      </a:r>
+                    </a:p>
+                  </a:txBody>
+                  <a:tcPr marL="91440" marR="91440" marT="36576" marB="36576">
+                    <a:solidFill>
+                      <a:srgbClr val="351C15"/>
+                    </a:solidFill>
+                  </a:tcPr>
+                </a:tc>
+                <a:tc>
+                  <a:txBody>
+                    <a:bodyPr wrap="square"/>
+                    <a:lstStyle/>
+                    <a:p>
+                      <a:r>
+                        <a:rPr sz="1400" b="1">
+                          <a:solidFill>
+                            <a:srgbClr val="FFFFFF"/>
+                          </a:solidFill>
+                          <a:latin typeface="Calibri"/>
+                        </a:rPr>
+                        <a:t>Per incident</a:t>
+                      </a:r>
+                    </a:p>
+                  </a:txBody>
+                  <a:tcPr marL="91440" marR="91440" marT="36576" marB="36576">
+                    <a:solidFill>
+                      <a:srgbClr val="351C15"/>
+                    </a:solidFill>
+                  </a:tcPr>
+                </a:tc>
+              </a:tr>
+              <a:tr h="384048">
+                <a:tc>
+                  <a:txBody>
+                    <a:bodyPr wrap="square"/>
+                    <a:lstStyle/>
+                    <a:p>
+                      <a:r>
+                        <a:rPr sz="1400" b="0">
+                          <a:solidFill>
+                            <a:srgbClr val="1F1F1F"/>
+                          </a:solidFill>
+                          <a:latin typeface="Calibri"/>
+                        </a:rPr>
+                        <a:t>Global average</a:t>
+                      </a:r>
+                    </a:p>
+                  </a:txBody>
+                  <a:tcPr marL="91440" marR="91440" marT="36576" marB="36576">
+                    <a:solidFill>
+                      <a:srgbClr val="F4F1EE"/>
+                    </a:solidFill>
+                  </a:tcPr>
+                </a:tc>
+                <a:tc>
+                  <a:txBody>
+                    <a:bodyPr wrap="square"/>
+                    <a:lstStyle/>
+                    <a:p>
+                      <a:r>
+                        <a:rPr sz="1400" b="1">
+                          <a:solidFill>
+                            <a:srgbClr val="C0392B"/>
+                          </a:solidFill>
+                          <a:latin typeface="Calibri"/>
+                        </a:rPr>
+                        <a:t>$4.88M</a:t>
+                      </a:r>
+                    </a:p>
+                  </a:txBody>
+                  <a:tcPr marL="91440" marR="91440" marT="36576" marB="36576">
+                    <a:solidFill>
+                      <a:srgbClr val="F4F1EE"/>
+                    </a:solidFill>
+                  </a:tcPr>
+                </a:tc>
+              </a:tr>
+              <a:tr h="384048">
+                <a:tc>
+                  <a:txBody>
+                    <a:bodyPr wrap="square"/>
+                    <a:lstStyle/>
+                    <a:p>
+                      <a:r>
+                        <a:rPr sz="1400" b="0">
+                          <a:solidFill>
+                            <a:srgbClr val="1F1F1F"/>
+                          </a:solidFill>
+                          <a:latin typeface="Calibri"/>
+                        </a:rPr>
+                        <a:t>United States average</a:t>
+                      </a:r>
+                    </a:p>
+                  </a:txBody>
+                  <a:tcPr marL="91440" marR="91440" marT="36576" marB="36576">
+                    <a:solidFill>
+                      <a:srgbClr val="FFFFFF"/>
+                    </a:solidFill>
+                  </a:tcPr>
+                </a:tc>
+                <a:tc>
+                  <a:txBody>
+                    <a:bodyPr wrap="square"/>
+                    <a:lstStyle/>
+                    <a:p>
+                      <a:r>
+                        <a:rPr sz="1400" b="1">
+                          <a:solidFill>
+                            <a:srgbClr val="C0392B"/>
+                          </a:solidFill>
+                          <a:latin typeface="Calibri"/>
+                        </a:rPr>
+                        <a:t>$9.36M</a:t>
+                      </a:r>
+                    </a:p>
+                  </a:txBody>
+                  <a:tcPr marL="91440" marR="91440" marT="36576" marB="36576">
+                    <a:solidFill>
+                      <a:srgbClr val="FFFFFF"/>
+                    </a:solidFill>
+                  </a:tcPr>
+                </a:tc>
+              </a:tr>
+              <a:tr h="384048">
+                <a:tc>
+                  <a:txBody>
+                    <a:bodyPr wrap="square"/>
+                    <a:lstStyle/>
+                    <a:p>
+                      <a:r>
+                        <a:rPr sz="1400" b="0">
+                          <a:solidFill>
+                            <a:srgbClr val="1F1F1F"/>
+                          </a:solidFill>
+                          <a:latin typeface="Calibri"/>
+                        </a:rPr>
+                        <a:t>Mean time to identify + contain</a:t>
+                      </a:r>
+                    </a:p>
+                  </a:txBody>
+                  <a:tcPr marL="91440" marR="91440" marT="36576" marB="36576">
+                    <a:solidFill>
+                      <a:srgbClr val="F4F1EE"/>
+                    </a:solidFill>
+                  </a:tcPr>
+                </a:tc>
+                <a:tc>
+                  <a:txBody>
+                    <a:bodyPr wrap="square"/>
+                    <a:lstStyle/>
+                    <a:p>
+                      <a:r>
+                        <a:rPr sz="1400" b="0">
+                          <a:solidFill>
+                            <a:srgbClr val="1F1F1F"/>
+                          </a:solidFill>
+                          <a:latin typeface="Calibri"/>
+                        </a:rPr>
+                        <a:t>258 days</a:t>
+                      </a:r>
+                    </a:p>
+                  </a:txBody>
+                  <a:tcPr marL="91440" marR="91440" marT="36576" marB="36576">
+                    <a:solidFill>
+                      <a:srgbClr val="F4F1EE"/>
+                    </a:solidFill>
+                  </a:tcPr>
+                </a:tc>
+              </a:tr>
+              <a:tr h="384048">
+                <a:tc>
+                  <a:txBody>
+                    <a:bodyPr wrap="square"/>
+                    <a:lstStyle/>
+                    <a:p>
+                      <a:r>
+                        <a:rPr sz="1400" b="0">
+                          <a:solidFill>
+                            <a:srgbClr val="1F1F1F"/>
+                          </a:solidFill>
+                          <a:latin typeface="Calibri"/>
+                        </a:rPr>
+                        <a:t>Not included: SLA credits, shipper churn</a:t>
+                      </a:r>
+                    </a:p>
+                  </a:txBody>
+                  <a:tcPr marL="91440" marR="91440" marT="36576" marB="36576">
+                    <a:solidFill>
+                      <a:srgbClr val="FFFFFF"/>
+                    </a:solidFill>
+                  </a:tcPr>
+                </a:tc>
+                <a:tc>
+                  <a:txBody>
+                    <a:bodyPr wrap="square"/>
+                    <a:lstStyle/>
+                    <a:p>
+                      <a:r>
+                        <a:rPr sz="1400" b="0">
+                          <a:solidFill>
+                            <a:srgbClr val="1F1F1F"/>
+                          </a:solidFill>
+                          <a:latin typeface="Calibri"/>
+                        </a:rPr>
+                        <a:t>UPS-internal figures</a:t>
+                      </a:r>
+                    </a:p>
+                  </a:txBody>
+                  <a:tcPr marL="91440" marR="91440" marT="36576" marB="36576">
+                    <a:solidFill>
+                      <a:srgbClr val="FFFFFF"/>
+                    </a:solidFill>
+                  </a:tcPr>
+                </a:tc>
+              </a:tr>
+            </a:tbl>
+          </a:graphicData>
+        </a:graphic>
+      </p:graphicFrame>
+      <p:sp>
+        <p:nvSpPr>
+          <p:cNvPr id="8" name="TextBox 7"/>
+          <p:cNvSpPr txBox="1"/>
+          <p:nvPr/>
+        </p:nvSpPr>
+        <p:spPr>
+          <a:xfrm>
+            <a:off x="548640" y="3520440"/>
+            <a:ext cx="6949440" cy="365760"/>
+          </a:xfrm>
+          <a:prstGeom prst="rect">
+            <a:avLst/>
+          </a:prstGeom>
+          <a:noFill/>
+        </p:spPr>
+        <p:txBody>
+          <a:bodyPr wrap="square">
+            <a:spAutoFit/>
+          </a:bodyPr>
+          <a:lstStyle/>
+          <a:p>
+            <a:pPr algn="l"/>
+            <a:r>
+              <a:rPr sz="1400" b="1">
+                <a:solidFill>
+                  <a:srgbClr val="351C15"/>
+                </a:solidFill>
+                <a:latin typeface="Calibri"/>
+              </a:rPr>
+              <a:t>Expected loss / yr  =  annual breach probability  ×  cost per breach</a:t>
+            </a:r>
+          </a:p>
+        </p:txBody>
+      </p:sp>
+      <p:graphicFrame>
+        <p:nvGraphicFramePr>
+          <p:cNvPr id="9" name="Table 8"/>
+          <p:cNvGraphicFramePr>
+            <a:graphicFrameLocks noGrp="1"/>
+          </p:cNvGraphicFramePr>
+          <p:nvPr/>
+        </p:nvGraphicFramePr>
+        <p:xfrm>
+          <a:off x="548640" y="3977639"/>
+          <a:ext cx="6949440" cy="1536192"/>
+        </p:xfrm>
+        <a:graphic>
+          <a:graphicData uri="http://schemas.openxmlformats.org/drawingml/2006/table">
+            <a:tbl>
+              <a:tblPr firstRow="1" bandRow="1">
+                <a:tableStyleId>{5C22544A-7EE6-4342-B048-85BDC9FD1C3A}</a:tableStyleId>
+              </a:tblPr>
+              <a:tblGrid>
+                <a:gridCol w="1554480"/>
+                <a:gridCol w="1645920"/>
+                <a:gridCol w="1828800"/>
+                <a:gridCol w="1920240"/>
+              </a:tblGrid>
+              <a:tr h="384048">
+                <a:tc>
+                  <a:txBody>
+                    <a:bodyPr wrap="square"/>
+                    <a:lstStyle/>
+                    <a:p>
+                      <a:r>
+                        <a:rPr sz="1400" b="1">
+                          <a:solidFill>
+                            <a:srgbClr val="FFFFFF"/>
+                          </a:solidFill>
+                          <a:latin typeface="Calibri"/>
+                        </a:rPr>
+                        <a:t>Scenario</a:t>
+                      </a:r>
+                    </a:p>
+                  </a:txBody>
+                  <a:tcPr marL="91440" marR="91440" marT="36576" marB="36576">
+                    <a:solidFill>
+                      <a:srgbClr val="351C15"/>
+                    </a:solidFill>
+                  </a:tcPr>
+                </a:tc>
+                <a:tc>
+                  <a:txBody>
+                    <a:bodyPr wrap="square"/>
+                    <a:lstStyle/>
+                    <a:p>
+                      <a:r>
+                        <a:rPr sz="1400" b="1">
+                          <a:solidFill>
+                            <a:srgbClr val="FFFFFF"/>
+                          </a:solidFill>
+                          <a:latin typeface="Calibri"/>
+                        </a:rPr>
+                        <a:t>Annual probability</a:t>
+                      </a:r>
+                    </a:p>
+                  </a:txBody>
+                  <a:tcPr marL="91440" marR="91440" marT="36576" marB="36576">
+                    <a:solidFill>
+                      <a:srgbClr val="351C15"/>
+                    </a:solidFill>
+                  </a:tcPr>
+                </a:tc>
+                <a:tc>
+                  <a:txBody>
+                    <a:bodyPr wrap="square"/>
+                    <a:lstStyle/>
+                    <a:p>
+                      <a:r>
+                        <a:rPr sz="1400" b="1">
+                          <a:solidFill>
+                            <a:srgbClr val="FFFFFF"/>
+                          </a:solidFill>
+                          <a:latin typeface="Calibri"/>
+                        </a:rPr>
+                        <a:t>Cost basis</a:t>
+                      </a:r>
+                    </a:p>
+                  </a:txBody>
+                  <a:tcPr marL="91440" marR="91440" marT="36576" marB="36576">
+                    <a:solidFill>
+                      <a:srgbClr val="351C15"/>
+                    </a:solidFill>
+                  </a:tcPr>
+                </a:tc>
+                <a:tc>
+                  <a:txBody>
+                    <a:bodyPr wrap="square"/>
+                    <a:lstStyle/>
+                    <a:p>
+                      <a:r>
+                        <a:rPr sz="1400" b="1">
+                          <a:solidFill>
+                            <a:srgbClr val="FFFFFF"/>
+                          </a:solidFill>
+                          <a:latin typeface="Calibri"/>
+                        </a:rPr>
+                        <a:t>Expected loss / yr</a:t>
+                      </a:r>
+                    </a:p>
+                  </a:txBody>
+                  <a:tcPr marL="91440" marR="91440" marT="36576" marB="36576">
+                    <a:solidFill>
+                      <a:srgbClr val="351C15"/>
+                    </a:solidFill>
+                  </a:tcPr>
+                </a:tc>
+              </a:tr>
+              <a:tr h="384048">
+                <a:tc>
+                  <a:txBody>
+                    <a:bodyPr wrap="square"/>
+                    <a:lstStyle/>
+                    <a:p>
+                      <a:r>
+                        <a:rPr sz="1400" b="0">
+                          <a:solidFill>
+                            <a:srgbClr val="1F1F1F"/>
+                          </a:solidFill>
+                          <a:latin typeface="Calibri"/>
+                        </a:rPr>
+                        <a:t>Conservative</a:t>
+                      </a:r>
+                    </a:p>
+                  </a:txBody>
+                  <a:tcPr marL="91440" marR="91440" marT="36576" marB="36576">
+                    <a:solidFill>
+                      <a:srgbClr val="F4F1EE"/>
+                    </a:solidFill>
+                  </a:tcPr>
+                </a:tc>
+                <a:tc>
+                  <a:txBody>
+                    <a:bodyPr wrap="square"/>
+                    <a:lstStyle/>
+                    <a:p>
+                      <a:r>
+                        <a:rPr sz="1400" b="0">
+                          <a:solidFill>
+                            <a:srgbClr val="1F1F1F"/>
+                          </a:solidFill>
+                          <a:latin typeface="Calibri"/>
+                        </a:rPr>
+                        <a:t>5%</a:t>
+                      </a:r>
+                    </a:p>
+                  </a:txBody>
+                  <a:tcPr marL="91440" marR="91440" marT="36576" marB="36576">
+                    <a:solidFill>
+                      <a:srgbClr val="F4F1EE"/>
+                    </a:solidFill>
+                  </a:tcPr>
+                </a:tc>
+                <a:tc>
+                  <a:txBody>
+                    <a:bodyPr wrap="square"/>
+                    <a:lstStyle/>
+                    <a:p>
+                      <a:r>
+                        <a:rPr sz="1400" b="0">
+                          <a:solidFill>
+                            <a:srgbClr val="1F1F1F"/>
+                          </a:solidFill>
+                          <a:latin typeface="Calibri"/>
+                        </a:rPr>
+                        <a:t>$4.88M global</a:t>
+                      </a:r>
+                    </a:p>
+                  </a:txBody>
+                  <a:tcPr marL="91440" marR="91440" marT="36576" marB="36576">
+                    <a:solidFill>
+                      <a:srgbClr val="F4F1EE"/>
+                    </a:solidFill>
+                  </a:tcPr>
+                </a:tc>
+                <a:tc>
+                  <a:txBody>
+                    <a:bodyPr wrap="square"/>
+                    <a:lstStyle/>
+                    <a:p>
+                      <a:r>
+                        <a:rPr sz="1400" b="1">
+                          <a:solidFill>
+                            <a:srgbClr val="C0392B"/>
+                          </a:solidFill>
+                          <a:latin typeface="Calibri"/>
+                        </a:rPr>
+                        <a:t>$0.24M</a:t>
+                      </a:r>
+                    </a:p>
+                  </a:txBody>
+                  <a:tcPr marL="91440" marR="91440" marT="36576" marB="36576">
+                    <a:solidFill>
+                      <a:srgbClr val="F4F1EE"/>
+                    </a:solidFill>
+                  </a:tcPr>
+                </a:tc>
+              </a:tr>
+              <a:tr h="384048">
+                <a:tc>
+                  <a:txBody>
+                    <a:bodyPr wrap="square"/>
+                    <a:lstStyle/>
+                    <a:p>
+                      <a:r>
+                        <a:rPr sz="1400" b="0">
+                          <a:solidFill>
+                            <a:srgbClr val="1F1F1F"/>
+                          </a:solidFill>
+                          <a:latin typeface="Calibri"/>
+                        </a:rPr>
+                        <a:t>Base</a:t>
+                      </a:r>
+                    </a:p>
+                  </a:txBody>
+                  <a:tcPr marL="91440" marR="91440" marT="36576" marB="36576">
+                    <a:solidFill>
+                      <a:srgbClr val="FFFFFF"/>
+                    </a:solidFill>
+                  </a:tcPr>
+                </a:tc>
+                <a:tc>
+                  <a:txBody>
+                    <a:bodyPr wrap="square"/>
+                    <a:lstStyle/>
+                    <a:p>
+                      <a:r>
+                        <a:rPr sz="1400" b="0">
+                          <a:solidFill>
+                            <a:srgbClr val="1F1F1F"/>
+                          </a:solidFill>
+                          <a:latin typeface="Calibri"/>
+                        </a:rPr>
+                        <a:t>10%</a:t>
+                      </a:r>
+                    </a:p>
+                  </a:txBody>
+                  <a:tcPr marL="91440" marR="91440" marT="36576" marB="36576">
+                    <a:solidFill>
+                      <a:srgbClr val="FFFFFF"/>
+                    </a:solidFill>
+                  </a:tcPr>
+                </a:tc>
+                <a:tc>
+                  <a:txBody>
+                    <a:bodyPr wrap="square"/>
+                    <a:lstStyle/>
+                    <a:p>
+                      <a:r>
+                        <a:rPr sz="1400" b="0">
+                          <a:solidFill>
+                            <a:srgbClr val="1F1F1F"/>
+                          </a:solidFill>
+                          <a:latin typeface="Calibri"/>
+                        </a:rPr>
+                        <a:t>$9.36M US</a:t>
+                      </a:r>
+                    </a:p>
+                  </a:txBody>
+                  <a:tcPr marL="91440" marR="91440" marT="36576" marB="36576">
+                    <a:solidFill>
+                      <a:srgbClr val="FFFFFF"/>
+                    </a:solidFill>
+                  </a:tcPr>
+                </a:tc>
+                <a:tc>
+                  <a:txBody>
+                    <a:bodyPr wrap="square"/>
+                    <a:lstStyle/>
+                    <a:p>
+                      <a:r>
+                        <a:rPr sz="1400" b="1">
+                          <a:solidFill>
+                            <a:srgbClr val="C0392B"/>
+                          </a:solidFill>
+                          <a:latin typeface="Calibri"/>
+                        </a:rPr>
+                        <a:t>$0.94M</a:t>
+                      </a:r>
+                    </a:p>
+                  </a:txBody>
+                  <a:tcPr marL="91440" marR="91440" marT="36576" marB="36576">
+                    <a:solidFill>
+                      <a:srgbClr val="FFFFFF"/>
+                    </a:solidFill>
+                  </a:tcPr>
+                </a:tc>
+              </a:tr>
+              <a:tr h="384048">
+                <a:tc>
+                  <a:txBody>
+                    <a:bodyPr wrap="square"/>
+                    <a:lstStyle/>
+                    <a:p>
+                      <a:r>
+                        <a:rPr sz="1400" b="0">
+                          <a:solidFill>
+                            <a:srgbClr val="1F1F1F"/>
+                          </a:solidFill>
+                          <a:latin typeface="Calibri"/>
+                        </a:rPr>
+                        <a:t>Adverse</a:t>
+                      </a:r>
+                    </a:p>
+                  </a:txBody>
+                  <a:tcPr marL="91440" marR="91440" marT="36576" marB="36576">
+                    <a:solidFill>
+                      <a:srgbClr val="F4F1EE"/>
+                    </a:solidFill>
+                  </a:tcPr>
+                </a:tc>
+                <a:tc>
+                  <a:txBody>
+                    <a:bodyPr wrap="square"/>
+                    <a:lstStyle/>
+                    <a:p>
+                      <a:r>
+                        <a:rPr sz="1400" b="0">
+                          <a:solidFill>
+                            <a:srgbClr val="1F1F1F"/>
+                          </a:solidFill>
+                          <a:latin typeface="Calibri"/>
+                        </a:rPr>
+                        <a:t>20%</a:t>
+                      </a:r>
+                    </a:p>
+                  </a:txBody>
+                  <a:tcPr marL="91440" marR="91440" marT="36576" marB="36576">
+                    <a:solidFill>
+                      <a:srgbClr val="F4F1EE"/>
+                    </a:solidFill>
+                  </a:tcPr>
+                </a:tc>
+                <a:tc>
+                  <a:txBody>
+                    <a:bodyPr wrap="square"/>
+                    <a:lstStyle/>
+                    <a:p>
+                      <a:r>
+                        <a:rPr sz="1400" b="0">
+                          <a:solidFill>
+                            <a:srgbClr val="1F1F1F"/>
+                          </a:solidFill>
+                          <a:latin typeface="Calibri"/>
+                        </a:rPr>
+                        <a:t>$9.36M US</a:t>
+                      </a:r>
+                    </a:p>
+                  </a:txBody>
+                  <a:tcPr marL="91440" marR="91440" marT="36576" marB="36576">
+                    <a:solidFill>
+                      <a:srgbClr val="F4F1EE"/>
+                    </a:solidFill>
+                  </a:tcPr>
+                </a:tc>
+                <a:tc>
+                  <a:txBody>
+                    <a:bodyPr wrap="square"/>
+                    <a:lstStyle/>
+                    <a:p>
+                      <a:r>
+                        <a:rPr sz="1400" b="1">
+                          <a:solidFill>
+                            <a:srgbClr val="C0392B"/>
+                          </a:solidFill>
+                          <a:latin typeface="Calibri"/>
+                        </a:rPr>
+                        <a:t>$1.87M</a:t>
+                      </a:r>
+                    </a:p>
+                  </a:txBody>
+                  <a:tcPr marL="91440" marR="91440" marT="36576" marB="36576">
+                    <a:solidFill>
+                      <a:srgbClr val="F4F1EE"/>
+                    </a:solidFill>
+                  </a:tcPr>
+                </a:tc>
+              </a:tr>
+            </a:tbl>
+          </a:graphicData>
+        </a:graphic>
+      </p:graphicFrame>
+      <p:sp>
+        <p:nvSpPr>
+          <p:cNvPr id="10" name="Rectangle 9"/>
           <p:cNvSpPr/>
           <p:nvPr/>
         </p:nvSpPr>
         <p:spPr>
           <a:xfrm>
-            <a:off x="548640" y="1463040"/>
-            <a:ext cx="1188720" cy="960120"/>
+            <a:off x="7772400" y="1371600"/>
+            <a:ext cx="3840480" cy="1417320"/>
+          </a:xfrm>
+          <a:prstGeom prst="rect">
+            <a:avLst/>
+          </a:prstGeom>
+          <a:solidFill>
+            <a:srgbClr val="F4F1EE"/>
+          </a:solidFill>
+          <a:ln>
+            <a:noFill/>
+          </a:ln>
+          <a:effectLst/>
+        </p:spPr>
+        <p:style>
+          <a:lnRef idx="1">
+            <a:schemeClr val="accent1"/>
+          </a:lnRef>
+          <a:fillRef idx="3">
+            <a:schemeClr val="accent1"/>
+          </a:fillRef>
+          <a:effectRef idx="2">
+            <a:schemeClr val="accent1"/>
+          </a:effectRef>
+          <a:fontRef idx="minor">
+            <a:schemeClr val="lt1"/>
+          </a:fontRef>
+        </p:style>
+        <p:txBody>
+          <a:bodyPr rtlCol="0" anchor="ctr"/>
+          <a:lstStyle/>
+          <a:p>
+            <a:pPr algn="ctr"/>
+          </a:p>
+        </p:txBody>
+      </p:sp>
+      <p:sp>
+        <p:nvSpPr>
+          <p:cNvPr id="11" name="Rectangle 10"/>
+          <p:cNvSpPr/>
+          <p:nvPr/>
+        </p:nvSpPr>
+        <p:spPr>
+          <a:xfrm>
+            <a:off x="7772400" y="1371600"/>
+            <a:ext cx="73152" cy="1417320"/>
           </a:xfrm>
           <a:prstGeom prst="rect">
             <a:avLst/>
@@ -9855,14 +10579,14 @@
       </p:sp>
       <p:sp>
         <p:nvSpPr>
-          <p:cNvPr id="8" name="TextBox 7"/>
+          <p:cNvPr id="12" name="TextBox 11"/>
           <p:cNvSpPr txBox="1"/>
           <p:nvPr/>
         </p:nvSpPr>
         <p:spPr>
           <a:xfrm>
-            <a:off x="548640" y="1737360"/>
-            <a:ext cx="1188720" cy="457200"/>
+            <a:off x="8001000" y="1463040"/>
+            <a:ext cx="3566160" cy="731520"/>
           </a:xfrm>
           <a:prstGeom prst="rect">
             <a:avLst/>
@@ -9875,29 +10599,64 @@
           </a:bodyPr>
           <a:lstStyle/>
           <a:p>
-            <a:pPr algn="ctr"/>
-            <a:r>
-              <a:rPr sz="1600" b="1">
+            <a:pPr algn="l"/>
+            <a:r>
+              <a:rPr sz="3200" b="1">
                 <a:solidFill>
                   <a:srgbClr val="351C15"/>
                 </a:solidFill>
                 <a:latin typeface="Calibri"/>
               </a:rPr>
-              <a:t>Done</a:t>
-            </a:r>
-          </a:p>
-        </p:txBody>
-      </p:sp>
-      <p:sp>
-        <p:nvSpPr>
-          <p:cNvPr id="9" name="Rectangle 8"/>
+              <a:t>$0.9M / yr</a:t>
+            </a:r>
+          </a:p>
+        </p:txBody>
+      </p:sp>
+      <p:sp>
+        <p:nvSpPr>
+          <p:cNvPr id="13" name="TextBox 12"/>
+          <p:cNvSpPr txBox="1"/>
+          <p:nvPr/>
+        </p:nvSpPr>
+        <p:spPr>
+          <a:xfrm>
+            <a:off x="8001000" y="2194560"/>
+            <a:ext cx="3566160" cy="548640"/>
+          </a:xfrm>
+          <a:prstGeom prst="rect">
+            <a:avLst/>
+          </a:prstGeom>
+          <a:noFill/>
+        </p:spPr>
+        <p:txBody>
+          <a:bodyPr wrap="square">
+            <a:spAutoFit/>
+          </a:bodyPr>
+          <a:lstStyle/>
+          <a:p>
+            <a:pPr algn="l"/>
+            <a:r>
+              <a:rPr sz="1300" b="0">
+                <a:solidFill>
+                  <a:srgbClr val="6B6B6B"/>
+                </a:solidFill>
+                <a:latin typeface="Calibri"/>
+              </a:rPr>
+              <a:t>base-case expected loss avoided by retiring the EOL stack</a:t>
+            </a:r>
+          </a:p>
+        </p:txBody>
+      </p:sp>
+      <p:sp>
+        <p:nvSpPr>
+          <p:cNvPr id="14" name="Rectangle 13"/>
           <p:cNvSpPr/>
           <p:nvPr/>
         </p:nvSpPr>
         <p:spPr>
           <a:xfrm>
-            <a:off x="1737360" y="1463040"/>
-            <a:ext cx="9875520" cy="960120"/>
+            <a:off x="7772400" y="3017520"/>
+            <a:ext cx="3840480" cy="1417320"/>
           </a:xfrm>
           <a:prstGeom prst="rect">
             <a:avLst/>
@@ -9934,84 +10693,14 @@
       </p:sp>
       <p:sp>
         <p:nvSpPr>
-          <p:cNvPr id="10" name="TextBox 9"/>
-          <p:cNvSpPr txBox="1"/>
-          <p:nvPr/>
-        </p:nvSpPr>
-        <p:spPr>
-          <a:xfrm>
-            <a:off x="1920240" y="1554480"/>
-            <a:ext cx="9509760" cy="365760"/>
-          </a:xfrm>
-          <a:prstGeom prst="rect">
-            <a:avLst/>
-          </a:prstGeom>
-          <a:noFill/>
-        </p:spPr>
-        <p:txBody>
-          <a:bodyPr wrap="square">
-            <a:spAutoFit/>
-          </a:bodyPr>
-          <a:lstStyle/>
-          <a:p>
-            <a:pPr algn="l"/>
-            <a:r>
-              <a:rPr sz="1700" b="1">
-                <a:solidFill>
-                  <a:srgbClr val="351C15"/>
-                </a:solidFill>
-                <a:latin typeface="Calibri"/>
-              </a:rPr>
-              <a:t>shipping module — PR #5</a:t>
-            </a:r>
-          </a:p>
-        </p:txBody>
-      </p:sp>
-      <p:sp>
-        <p:nvSpPr>
-          <p:cNvPr id="11" name="TextBox 10"/>
-          <p:cNvSpPr txBox="1"/>
-          <p:nvPr/>
-        </p:nvSpPr>
-        <p:spPr>
-          <a:xfrm>
-            <a:off x="1920240" y="1920240"/>
-            <a:ext cx="9509760" cy="502920"/>
-          </a:xfrm>
-          <a:prstGeom prst="rect">
-            <a:avLst/>
-          </a:prstGeom>
-          <a:noFill/>
-        </p:spPr>
-        <p:txBody>
-          <a:bodyPr wrap="square">
-            <a:spAutoFit/>
-          </a:bodyPr>
-          <a:lstStyle/>
-          <a:p>
-            <a:pPr algn="l"/>
-            <a:r>
-              <a:rPr sz="1300" b="0">
-                <a:solidFill>
-                  <a:srgbClr val="1F1F1F"/>
-                </a:solidFill>
-                <a:latin typeface="Calibri"/>
-              </a:rPr>
-              <a:t>Same recipe on the next revenue module: 381 → 158 pom lines, 10 live CIE tests gated, new offline OAuth → Ship happy-path test, green on JDK 21. main still fails today — the live ‘before’ for the meeting.</a:t>
-            </a:r>
-          </a:p>
-        </p:txBody>
-      </p:sp>
-      <p:sp>
-        <p:nvSpPr>
-          <p:cNvPr id="12" name="Rectangle 11"/>
+          <p:cNvPr id="15" name="Rectangle 14"/>
           <p:cNvSpPr/>
           <p:nvPr/>
         </p:nvSpPr>
         <p:spPr>
           <a:xfrm>
-            <a:off x="548640" y="2560320"/>
-            <a:ext cx="1188720" cy="960120"/>
+            <a:off x="7772400" y="3017520"/>
+            <a:ext cx="73152" cy="1417320"/>
           </a:xfrm>
           <a:prstGeom prst="rect">
             <a:avLst/>
@@ -10048,14 +10737,14 @@
       </p:sp>
       <p:sp>
         <p:nvSpPr>
-          <p:cNvPr id="13" name="TextBox 12"/>
+          <p:cNvPr id="16" name="TextBox 15"/>
           <p:cNvSpPr txBox="1"/>
           <p:nvPr/>
         </p:nvSpPr>
         <p:spPr>
           <a:xfrm>
-            <a:off x="548640" y="2834640"/>
-            <a:ext cx="1188720" cy="457200"/>
+            <a:off x="8001000" y="3108960"/>
+            <a:ext cx="3566160" cy="731520"/>
           </a:xfrm>
           <a:prstGeom prst="rect">
             <a:avLst/>
@@ -10068,7 +10757,528 @@
           </a:bodyPr>
           <a:lstStyle/>
           <a:p>
+            <a:pPr algn="l"/>
+            <a:r>
+              <a:rPr sz="3200" b="1">
+                <a:solidFill>
+                  <a:srgbClr val="351C15"/>
+                </a:solidFill>
+                <a:latin typeface="Calibri"/>
+              </a:rPr>
+              <a:t>~6–19×</a:t>
+            </a:r>
+          </a:p>
+        </p:txBody>
+      </p:sp>
+      <p:sp>
+        <p:nvSpPr>
+          <p:cNvPr id="17" name="TextBox 16"/>
+          <p:cNvSpPr txBox="1"/>
+          <p:nvPr/>
+        </p:nvSpPr>
+        <p:spPr>
+          <a:xfrm>
+            <a:off x="8001000" y="3840480"/>
+            <a:ext cx="3566160" cy="548640"/>
+          </a:xfrm>
+          <a:prstGeom prst="rect">
+            <a:avLst/>
+          </a:prstGeom>
+          <a:noFill/>
+        </p:spPr>
+        <p:txBody>
+          <a:bodyPr wrap="square">
+            <a:spAutoFit/>
+          </a:bodyPr>
+          <a:lstStyle/>
+          <a:p>
+            <a:pPr algn="l"/>
+            <a:r>
+              <a:rPr sz="1300" b="0">
+                <a:solidFill>
+                  <a:srgbClr val="6B6B6B"/>
+                </a:solidFill>
+                <a:latin typeface="Calibri"/>
+              </a:rPr>
+              <a:t>base-case avoided loss vs. Devin cost of upgrading 100 services ($50–150k)</a:t>
+            </a:r>
+          </a:p>
+        </p:txBody>
+      </p:sp>
+      <p:sp>
+        <p:nvSpPr>
+          <p:cNvPr id="18" name="Rectangle 17"/>
+          <p:cNvSpPr/>
+          <p:nvPr/>
+        </p:nvSpPr>
+        <p:spPr>
+          <a:xfrm>
+            <a:off x="7772400" y="4663440"/>
+            <a:ext cx="3840480" cy="1554480"/>
+          </a:xfrm>
+          <a:prstGeom prst="rect">
+            <a:avLst/>
+          </a:prstGeom>
+          <a:solidFill>
+            <a:srgbClr val="351C15"/>
+          </a:solidFill>
+          <a:ln>
+            <a:noFill/>
+          </a:ln>
+          <a:effectLst/>
+        </p:spPr>
+        <p:style>
+          <a:lnRef idx="1">
+            <a:schemeClr val="accent1"/>
+          </a:lnRef>
+          <a:fillRef idx="3">
+            <a:schemeClr val="accent1"/>
+          </a:fillRef>
+          <a:effectRef idx="2">
+            <a:schemeClr val="accent1"/>
+          </a:effectRef>
+          <a:fontRef idx="minor">
+            <a:schemeClr val="lt1"/>
+          </a:fontRef>
+        </p:style>
+        <p:txBody>
+          <a:bodyPr rtlCol="0" anchor="ctr"/>
+          <a:lstStyle/>
+          <a:p>
             <a:pPr algn="ctr"/>
+          </a:p>
+        </p:txBody>
+      </p:sp>
+      <p:sp>
+        <p:nvSpPr>
+          <p:cNvPr id="19" name="TextBox 18"/>
+          <p:cNvSpPr txBox="1"/>
+          <p:nvPr/>
+        </p:nvSpPr>
+        <p:spPr>
+          <a:xfrm>
+            <a:off x="7955279" y="4754880"/>
+            <a:ext cx="3566160" cy="1371600"/>
+          </a:xfrm>
+          <a:prstGeom prst="rect">
+            <a:avLst/>
+          </a:prstGeom>
+          <a:noFill/>
+        </p:spPr>
+        <p:txBody>
+          <a:bodyPr wrap="square">
+            <a:spAutoFit/>
+          </a:bodyPr>
+          <a:lstStyle/>
+          <a:p>
+            <a:pPr algn="l"/>
+            <a:r>
+              <a:rPr sz="1200" b="0">
+                <a:solidFill>
+                  <a:srgbClr val="FFFFFF"/>
+                </a:solidFill>
+                <a:latin typeface="Calibri"/>
+              </a:rPr>
+              <a:t>Why the probability is non-zero</a:t>
+            </a:r>
+          </a:p>
+          <a:p>
+            <a:pPr algn="l"/>
+            <a:r>
+              <a:rPr sz="1200" b="0">
+                <a:solidFill>
+                  <a:srgbClr val="FFFFFF"/>
+                </a:solidFill>
+                <a:latin typeface="Calibri"/>
+              </a:rPr>
+              <a:t>Spring Framework 5.3 left OSS support Aug 2024 and Boot 2.7 in Nov 2023: new CVEs get no free patch. Spring4Shell (CVE-2022-22965) hit exactly this line.</a:t>
+            </a:r>
+          </a:p>
+        </p:txBody>
+      </p:sp>
+      <p:sp>
+        <p:nvSpPr>
+          <p:cNvPr id="20" name="TextBox 19"/>
+          <p:cNvSpPr txBox="1"/>
+          <p:nvPr/>
+        </p:nvSpPr>
+        <p:spPr>
+          <a:xfrm>
+            <a:off x="548640" y="5669280"/>
+            <a:ext cx="6949440" cy="731520"/>
+          </a:xfrm>
+          <a:prstGeom prst="rect">
+            <a:avLst/>
+          </a:prstGeom>
+          <a:noFill/>
+        </p:spPr>
+        <p:txBody>
+          <a:bodyPr wrap="square">
+            <a:spAutoFit/>
+          </a:bodyPr>
+          <a:lstStyle/>
+          <a:p>
+            <a:pPr algn="l"/>
+            <a:r>
+              <a:rPr sz="1100" b="0">
+                <a:solidFill>
+                  <a:srgbClr val="6B6B6B"/>
+                </a:solidFill>
+                <a:latin typeface="Calibri"/>
+              </a:rPr>
+              <a:t>Probabilities are placeholders for UPS product-security to replace with their own risk register. Benchmarks are per-incident averages, not UPS figures; a single Track/Ship incident is the whole number, not the expected value.</a:t>
+            </a:r>
+          </a:p>
+        </p:txBody>
+      </p:sp>
+      <p:sp>
+        <p:nvSpPr>
+          <p:cNvPr id="21" name="TextBox 20"/>
+          <p:cNvSpPr txBox="1"/>
+          <p:nvPr/>
+        </p:nvSpPr>
+        <p:spPr>
+          <a:xfrm>
+            <a:off x="548640" y="6446520"/>
+            <a:ext cx="7315200" cy="274320"/>
+          </a:xfrm>
+          <a:prstGeom prst="rect">
+            <a:avLst/>
+          </a:prstGeom>
+          <a:noFill/>
+        </p:spPr>
+        <p:txBody>
+          <a:bodyPr wrap="square">
+            <a:spAutoFit/>
+          </a:bodyPr>
+          <a:lstStyle/>
+          <a:p>
+            <a:pPr algn="l"/>
+            <a:r>
+              <a:rPr sz="1000" b="0">
+                <a:solidFill>
+                  <a:srgbClr val="6B6B6B"/>
+                </a:solidFill>
+                <a:latin typeface="Calibri"/>
+              </a:rPr>
+              <a:t>Fork of UPS-API/java-api-examples  •  PR #1 merged: github.com/matth4922-droid/UPS-java-api-examples/pull/1</a:t>
+            </a:r>
+          </a:p>
+        </p:txBody>
+      </p:sp>
+      <p:sp>
+        <p:nvSpPr>
+          <p:cNvPr id="22" name="TextBox 21"/>
+          <p:cNvSpPr txBox="1"/>
+          <p:nvPr/>
+        </p:nvSpPr>
+        <p:spPr>
+          <a:xfrm>
+            <a:off x="11155680" y="6446520"/>
+            <a:ext cx="548640" cy="274320"/>
+          </a:xfrm>
+          <a:prstGeom prst="rect">
+            <a:avLst/>
+          </a:prstGeom>
+          <a:noFill/>
+        </p:spPr>
+        <p:txBody>
+          <a:bodyPr wrap="square">
+            <a:spAutoFit/>
+          </a:bodyPr>
+          <a:lstStyle/>
+          <a:p>
+            <a:pPr algn="r"/>
+            <a:r>
+              <a:rPr sz="1000" b="0">
+                <a:solidFill>
+                  <a:srgbClr val="6B6B6B"/>
+                </a:solidFill>
+                <a:latin typeface="Calibri"/>
+              </a:rPr>
+              <a:t>8</a:t>
+            </a:r>
+          </a:p>
+        </p:txBody>
+      </p:sp>
+    </p:spTree>
+  </p:cSld>
+  <p:clrMapOvr>
+    <a:masterClrMapping/>
+  </p:clrMapOvr>
+</p:sld>
+</file>
+
+<file path=ppt/slides/slide9.xml><?xml version="1.0" encoding="utf-8"?>
+<p:sld xmlns:a="http://schemas.openxmlformats.org/drawingml/2006/main" xmlns:p="http://schemas.openxmlformats.org/presentationml/2006/main" xmlns:r="http://schemas.openxmlformats.org/officeDocument/2006/relationships">
+  <p:cSld>
+    <p:spTree>
+      <p:nvGrpSpPr>
+        <p:cNvPr id="1" name=""/>
+        <p:cNvGrpSpPr/>
+        <p:nvPr/>
+      </p:nvGrpSpPr>
+      <p:grpSpPr/>
+      <p:sp>
+        <p:nvSpPr>
+          <p:cNvPr id="2" name="Rectangle 1"/>
+          <p:cNvSpPr/>
+          <p:nvPr/>
+        </p:nvSpPr>
+        <p:spPr>
+          <a:xfrm>
+            <a:off x="0" y="0"/>
+            <a:ext cx="12191695" cy="1051560"/>
+          </a:xfrm>
+          <a:prstGeom prst="rect">
+            <a:avLst/>
+          </a:prstGeom>
+          <a:solidFill>
+            <a:srgbClr val="351C15"/>
+          </a:solidFill>
+          <a:ln>
+            <a:noFill/>
+          </a:ln>
+          <a:effectLst/>
+        </p:spPr>
+        <p:style>
+          <a:lnRef idx="1">
+            <a:schemeClr val="accent1"/>
+          </a:lnRef>
+          <a:fillRef idx="3">
+            <a:schemeClr val="accent1"/>
+          </a:fillRef>
+          <a:effectRef idx="2">
+            <a:schemeClr val="accent1"/>
+          </a:effectRef>
+          <a:fontRef idx="minor">
+            <a:schemeClr val="lt1"/>
+          </a:fontRef>
+        </p:style>
+        <p:txBody>
+          <a:bodyPr rtlCol="0" anchor="ctr"/>
+          <a:lstStyle/>
+          <a:p>
+            <a:pPr algn="ctr"/>
+          </a:p>
+        </p:txBody>
+      </p:sp>
+      <p:sp>
+        <p:nvSpPr>
+          <p:cNvPr id="3" name="Rectangle 2"/>
+          <p:cNvSpPr/>
+          <p:nvPr/>
+        </p:nvSpPr>
+        <p:spPr>
+          <a:xfrm>
+            <a:off x="0" y="1051560"/>
+            <a:ext cx="12191695" cy="73152"/>
+          </a:xfrm>
+          <a:prstGeom prst="rect">
+            <a:avLst/>
+          </a:prstGeom>
+          <a:solidFill>
+            <a:srgbClr val="FFB500"/>
+          </a:solidFill>
+          <a:ln>
+            <a:noFill/>
+          </a:ln>
+          <a:effectLst/>
+        </p:spPr>
+        <p:style>
+          <a:lnRef idx="1">
+            <a:schemeClr val="accent1"/>
+          </a:lnRef>
+          <a:fillRef idx="3">
+            <a:schemeClr val="accent1"/>
+          </a:fillRef>
+          <a:effectRef idx="2">
+            <a:schemeClr val="accent1"/>
+          </a:effectRef>
+          <a:fontRef idx="minor">
+            <a:schemeClr val="lt1"/>
+          </a:fontRef>
+        </p:style>
+        <p:txBody>
+          <a:bodyPr rtlCol="0" anchor="ctr"/>
+          <a:lstStyle/>
+          <a:p>
+            <a:pPr algn="ctr"/>
+          </a:p>
+        </p:txBody>
+      </p:sp>
+      <p:sp>
+        <p:nvSpPr>
+          <p:cNvPr id="4" name="TextBox 3"/>
+          <p:cNvSpPr txBox="1"/>
+          <p:nvPr/>
+        </p:nvSpPr>
+        <p:spPr>
+          <a:xfrm>
+            <a:off x="548640" y="201168"/>
+            <a:ext cx="10058400" cy="731520"/>
+          </a:xfrm>
+          <a:prstGeom prst="rect">
+            <a:avLst/>
+          </a:prstGeom>
+          <a:noFill/>
+        </p:spPr>
+        <p:txBody>
+          <a:bodyPr wrap="square">
+            <a:spAutoFit/>
+          </a:bodyPr>
+          <a:lstStyle/>
+          <a:p>
+            <a:pPr algn="l"/>
+            <a:r>
+              <a:rPr sz="2600" b="1">
+                <a:solidFill>
+                  <a:srgbClr val="FFFFFF"/>
+                </a:solidFill>
+                <a:latin typeface="Calibri"/>
+              </a:rPr>
+              <a:t>Next steps</a:t>
+            </a:r>
+          </a:p>
+        </p:txBody>
+      </p:sp>
+      <p:sp>
+        <p:nvSpPr>
+          <p:cNvPr id="5" name="TextBox 4"/>
+          <p:cNvSpPr txBox="1"/>
+          <p:nvPr/>
+        </p:nvSpPr>
+        <p:spPr>
+          <a:xfrm>
+            <a:off x="548640" y="658368"/>
+            <a:ext cx="10058400" cy="365760"/>
+          </a:xfrm>
+          <a:prstGeom prst="rect">
+            <a:avLst/>
+          </a:prstGeom>
+          <a:noFill/>
+        </p:spPr>
+        <p:txBody>
+          <a:bodyPr wrap="square">
+            <a:spAutoFit/>
+          </a:bodyPr>
+          <a:lstStyle/>
+          <a:p>
+            <a:pPr algn="l"/>
+            <a:r>
+              <a:rPr sz="1400" b="0">
+                <a:solidFill>
+                  <a:srgbClr val="FFB500"/>
+                </a:solidFill>
+                <a:latin typeface="Calibri"/>
+              </a:rPr>
+              <a:t>From one proven module to a portfolio program</a:t>
+            </a:r>
+          </a:p>
+        </p:txBody>
+      </p:sp>
+      <p:sp>
+        <p:nvSpPr>
+          <p:cNvPr id="6" name="TextBox 5"/>
+          <p:cNvSpPr txBox="1"/>
+          <p:nvPr/>
+        </p:nvSpPr>
+        <p:spPr>
+          <a:xfrm>
+            <a:off x="9875520" y="320040"/>
+            <a:ext cx="2103120" cy="457200"/>
+          </a:xfrm>
+          <a:prstGeom prst="rect">
+            <a:avLst/>
+          </a:prstGeom>
+          <a:noFill/>
+        </p:spPr>
+        <p:txBody>
+          <a:bodyPr wrap="square">
+            <a:spAutoFit/>
+          </a:bodyPr>
+          <a:lstStyle/>
+          <a:p>
+            <a:pPr algn="r"/>
+            <a:r>
+              <a:rPr sz="1400" b="1">
+                <a:solidFill>
+                  <a:srgbClr val="FFB500"/>
+                </a:solidFill>
+                <a:latin typeface="Calibri"/>
+              </a:rPr>
+              <a:t>Devin  ×  UPS</a:t>
+            </a:r>
+          </a:p>
+        </p:txBody>
+      </p:sp>
+      <p:sp>
+        <p:nvSpPr>
+          <p:cNvPr id="7" name="Rectangle 6"/>
+          <p:cNvSpPr/>
+          <p:nvPr/>
+        </p:nvSpPr>
+        <p:spPr>
+          <a:xfrm>
+            <a:off x="548640" y="1463040"/>
+            <a:ext cx="1188720" cy="960120"/>
+          </a:xfrm>
+          <a:prstGeom prst="rect">
+            <a:avLst/>
+          </a:prstGeom>
+          <a:solidFill>
+            <a:srgbClr val="FFB500"/>
+          </a:solidFill>
+          <a:ln>
+            <a:noFill/>
+          </a:ln>
+          <a:effectLst/>
+        </p:spPr>
+        <p:style>
+          <a:lnRef idx="1">
+            <a:schemeClr val="accent1"/>
+          </a:lnRef>
+          <a:fillRef idx="3">
+            <a:schemeClr val="accent1"/>
+          </a:fillRef>
+          <a:effectRef idx="2">
+            <a:schemeClr val="accent1"/>
+          </a:effectRef>
+          <a:fontRef idx="minor">
+            <a:schemeClr val="lt1"/>
+          </a:fontRef>
+        </p:style>
+        <p:txBody>
+          <a:bodyPr rtlCol="0" anchor="ctr"/>
+          <a:lstStyle/>
+          <a:p>
+            <a:pPr algn="ctr"/>
+          </a:p>
+        </p:txBody>
+      </p:sp>
+      <p:sp>
+        <p:nvSpPr>
+          <p:cNvPr id="8" name="TextBox 7"/>
+          <p:cNvSpPr txBox="1"/>
+          <p:nvPr/>
+        </p:nvSpPr>
+        <p:spPr>
+          <a:xfrm>
+            <a:off x="548640" y="1737360"/>
+            <a:ext cx="1188720" cy="457200"/>
+          </a:xfrm>
+          <a:prstGeom prst="rect">
+            <a:avLst/>
+          </a:prstGeom>
+          <a:noFill/>
+        </p:spPr>
+        <p:txBody>
+          <a:bodyPr wrap="square">
+            <a:spAutoFit/>
+          </a:bodyPr>
+          <a:lstStyle/>
+          <a:p>
+            <a:pPr algn="ctr"/>
             <a:r>
               <a:rPr sz="1600" b="1">
                 <a:solidFill>
@@ -10083,13 +11293,13 @@
       </p:sp>
       <p:sp>
         <p:nvSpPr>
-          <p:cNvPr id="14" name="Rectangle 13"/>
+          <p:cNvPr id="9" name="Rectangle 8"/>
           <p:cNvSpPr/>
           <p:nvPr/>
         </p:nvSpPr>
         <p:spPr>
           <a:xfrm>
-            <a:off x="1737360" y="2560320"/>
+            <a:off x="1737360" y="1463040"/>
             <a:ext cx="9875520" cy="960120"/>
           </a:xfrm>
           <a:prstGeom prst="rect">
@@ -10127,13 +11337,13 @@
       </p:sp>
       <p:sp>
         <p:nvSpPr>
-          <p:cNvPr id="15" name="TextBox 14"/>
+          <p:cNvPr id="10" name="TextBox 9"/>
           <p:cNvSpPr txBox="1"/>
           <p:nvPr/>
         </p:nvSpPr>
         <p:spPr>
           <a:xfrm>
-            <a:off x="1920240" y="2651760"/>
+            <a:off x="1920240" y="1554480"/>
             <a:ext cx="9509760" cy="365760"/>
           </a:xfrm>
           <a:prstGeom prst="rect">
@@ -10155,20 +11365,20 @@
                 </a:solidFill>
                 <a:latin typeface="Calibri"/>
               </a:rPr>
-              <a:t>Close the loop with CI — PR #4</a:t>
-            </a:r>
-          </a:p>
-        </p:txBody>
-      </p:sp>
-      <p:sp>
-        <p:nvSpPr>
-          <p:cNvPr id="16" name="TextBox 15"/>
+              <a:t>shipping module — PR #5</a:t>
+            </a:r>
+          </a:p>
+        </p:txBody>
+      </p:sp>
+      <p:sp>
+        <p:nvSpPr>
+          <p:cNvPr id="11" name="TextBox 10"/>
           <p:cNvSpPr txBox="1"/>
           <p:nvPr/>
         </p:nvSpPr>
         <p:spPr>
           <a:xfrm>
-            <a:off x="1920240" y="3017520"/>
+            <a:off x="1920240" y="1920240"/>
             <a:ext cx="9509760" cy="502920"/>
           </a:xfrm>
           <a:prstGeom prst="rect">
@@ -10190,20 +11400,20 @@
                 </a:solidFill>
                 <a:latin typeface="Calibri"/>
               </a:rPr>
-              <a:t>GitHub Actions builds upgraded modules on JDK 21 on every PR, so each Devin PR ends in a visible green check.</a:t>
-            </a:r>
-          </a:p>
-        </p:txBody>
-      </p:sp>
-      <p:sp>
-        <p:nvSpPr>
-          <p:cNvPr id="17" name="Rectangle 16"/>
+              <a:t>Same recipe on the next revenue module: 381 → 158 pom lines, 10 live CIE tests gated, new offline OAuth → Ship happy-path test, green on JDK 21. main still fails today — the live ‘before’ for the meeting.</a:t>
+            </a:r>
+          </a:p>
+        </p:txBody>
+      </p:sp>
+      <p:sp>
+        <p:nvSpPr>
+          <p:cNvPr id="12" name="Rectangle 11"/>
           <p:cNvSpPr/>
           <p:nvPr/>
         </p:nvSpPr>
         <p:spPr>
           <a:xfrm>
-            <a:off x="548640" y="3657600"/>
+            <a:off x="548640" y="2560320"/>
             <a:ext cx="1188720" cy="960120"/>
           </a:xfrm>
           <a:prstGeom prst="rect">
@@ -10241,13 +11451,13 @@
       </p:sp>
       <p:sp>
         <p:nvSpPr>
-          <p:cNvPr id="18" name="TextBox 17"/>
+          <p:cNvPr id="13" name="TextBox 12"/>
           <p:cNvSpPr txBox="1"/>
           <p:nvPr/>
         </p:nvSpPr>
         <p:spPr>
           <a:xfrm>
-            <a:off x="548640" y="3931920"/>
+            <a:off x="548640" y="2834640"/>
             <a:ext cx="1188720" cy="457200"/>
           </a:xfrm>
           <a:prstGeom prst="rect">
@@ -10269,20 +11479,20 @@
                 </a:solidFill>
                 <a:latin typeface="Calibri"/>
               </a:rPr>
-              <a:t>Next</a:t>
-            </a:r>
-          </a:p>
-        </p:txBody>
-      </p:sp>
-      <p:sp>
-        <p:nvSpPr>
-          <p:cNvPr id="19" name="Rectangle 18"/>
+              <a:t>Done</a:t>
+            </a:r>
+          </a:p>
+        </p:txBody>
+      </p:sp>
+      <p:sp>
+        <p:nvSpPr>
+          <p:cNvPr id="14" name="Rectangle 13"/>
           <p:cNvSpPr/>
           <p:nvPr/>
         </p:nvSpPr>
         <p:spPr>
           <a:xfrm>
-            <a:off x="1737360" y="3657600"/>
+            <a:off x="1737360" y="2560320"/>
             <a:ext cx="9875520" cy="960120"/>
           </a:xfrm>
           <a:prstGeom prst="rect">
@@ -10320,13 +11530,13 @@
       </p:sp>
       <p:sp>
         <p:nvSpPr>
-          <p:cNvPr id="20" name="TextBox 19"/>
+          <p:cNvPr id="15" name="TextBox 14"/>
           <p:cNvSpPr txBox="1"/>
           <p:nvPr/>
         </p:nvSpPr>
         <p:spPr>
           <a:xfrm>
-            <a:off x="1920240" y="3749040"/>
+            <a:off x="1920240" y="2651760"/>
             <a:ext cx="9509760" cy="365760"/>
           </a:xfrm>
           <a:prstGeom prst="rect">
@@ -10348,20 +11558,20 @@
                 </a:solidFill>
                 <a:latin typeface="Calibri"/>
               </a:rPr>
-              <a:t>Pilot on one internal UPS Spring service</a:t>
-            </a:r>
-          </a:p>
-        </p:txBody>
-      </p:sp>
-      <p:sp>
-        <p:nvSpPr>
-          <p:cNvPr id="21" name="TextBox 20"/>
+              <a:t>Close the loop with CI — PR #4</a:t>
+            </a:r>
+          </a:p>
+        </p:txBody>
+      </p:sp>
+      <p:sp>
+        <p:nvSpPr>
+          <p:cNvPr id="16" name="TextBox 15"/>
           <p:cNvSpPr txBox="1"/>
           <p:nvPr/>
         </p:nvSpPr>
         <p:spPr>
           <a:xfrm>
-            <a:off x="1920240" y="4114800"/>
+            <a:off x="1920240" y="3017520"/>
             <a:ext cx="9509760" cy="502920"/>
           </a:xfrm>
           <a:prstGeom prst="rect">
@@ -10383,20 +11593,20 @@
                 </a:solidFill>
                 <a:latin typeface="Calibri"/>
               </a:rPr>
-              <a:t>Same before/after evidence format, UPS-internal rates plugged into the ROI model, inside UPS’s repo and review process.</a:t>
-            </a:r>
-          </a:p>
-        </p:txBody>
-      </p:sp>
-      <p:sp>
-        <p:nvSpPr>
-          <p:cNvPr id="22" name="Rectangle 21"/>
+              <a:t>GitHub Actions builds upgraded modules on JDK 21 on every PR, so each Devin PR ends in a visible green check.</a:t>
+            </a:r>
+          </a:p>
+        </p:txBody>
+      </p:sp>
+      <p:sp>
+        <p:nvSpPr>
+          <p:cNvPr id="17" name="Rectangle 16"/>
           <p:cNvSpPr/>
           <p:nvPr/>
         </p:nvSpPr>
         <p:spPr>
           <a:xfrm>
-            <a:off x="548640" y="4754880"/>
+            <a:off x="548640" y="3657600"/>
             <a:ext cx="1188720" cy="960120"/>
           </a:xfrm>
           <a:prstGeom prst="rect">
@@ -10434,13 +11644,13 @@
       </p:sp>
       <p:sp>
         <p:nvSpPr>
-          <p:cNvPr id="23" name="TextBox 22"/>
+          <p:cNvPr id="18" name="TextBox 17"/>
           <p:cNvSpPr txBox="1"/>
           <p:nvPr/>
         </p:nvSpPr>
         <p:spPr>
           <a:xfrm>
-            <a:off x="548640" y="5029200"/>
+            <a:off x="548640" y="3931920"/>
             <a:ext cx="1188720" cy="457200"/>
           </a:xfrm>
           <a:prstGeom prst="rect">
@@ -10462,20 +11672,20 @@
                 </a:solidFill>
                 <a:latin typeface="Calibri"/>
               </a:rPr>
-              <a:t>Then</a:t>
-            </a:r>
-          </a:p>
-        </p:txBody>
-      </p:sp>
-      <p:sp>
-        <p:nvSpPr>
-          <p:cNvPr id="24" name="Rectangle 23"/>
+              <a:t>Next</a:t>
+            </a:r>
+          </a:p>
+        </p:txBody>
+      </p:sp>
+      <p:sp>
+        <p:nvSpPr>
+          <p:cNvPr id="19" name="Rectangle 18"/>
           <p:cNvSpPr/>
           <p:nvPr/>
         </p:nvSpPr>
         <p:spPr>
           <a:xfrm>
-            <a:off x="1737360" y="4754880"/>
+            <a:off x="1737360" y="3657600"/>
             <a:ext cx="9875520" cy="960120"/>
           </a:xfrm>
           <a:prstGeom prst="rect">
@@ -10513,13 +11723,13 @@
       </p:sp>
       <p:sp>
         <p:nvSpPr>
-          <p:cNvPr id="25" name="TextBox 24"/>
+          <p:cNvPr id="20" name="TextBox 19"/>
           <p:cNvSpPr txBox="1"/>
           <p:nvPr/>
         </p:nvSpPr>
         <p:spPr>
           <a:xfrm>
-            <a:off x="1920240" y="4846320"/>
+            <a:off x="1920240" y="3749040"/>
             <a:ext cx="9509760" cy="365760"/>
           </a:xfrm>
           <a:prstGeom prst="rect">
@@ -10541,20 +11751,20 @@
                 </a:solidFill>
                 <a:latin typeface="Calibri"/>
               </a:rPr>
-              <a:t>Portfolio run</a:t>
-            </a:r>
-          </a:p>
-        </p:txBody>
-      </p:sp>
-      <p:sp>
-        <p:nvSpPr>
-          <p:cNvPr id="26" name="TextBox 25"/>
+              <a:t>Pilot on one internal UPS Spring service</a:t>
+            </a:r>
+          </a:p>
+        </p:txBody>
+      </p:sp>
+      <p:sp>
+        <p:nvSpPr>
+          <p:cNvPr id="21" name="TextBox 20"/>
           <p:cNvSpPr txBox="1"/>
           <p:nvPr/>
         </p:nvSpPr>
         <p:spPr>
           <a:xfrm>
-            <a:off x="1920240" y="5212080"/>
+            <a:off x="1920240" y="4114800"/>
             <a:ext cx="9509760" cy="502920"/>
           </a:xfrm>
           <a:prstGeom prst="rect">
@@ -10576,21 +11786,65 @@
                 </a:solidFill>
                 <a:latin typeface="Calibri"/>
               </a:rPr>
-              <a:t>Inventory Spring 2.x / Java 8 services; Devin runs the upgrade in parallel, engineers review, product-security gets the evidence pack.</a:t>
-            </a:r>
-          </a:p>
-        </p:txBody>
-      </p:sp>
-      <p:sp>
-        <p:nvSpPr>
-          <p:cNvPr id="27" name="TextBox 26"/>
+              <a:t>Same before/after evidence format, UPS-internal rates plugged into the ROI model, inside UPS’s repo and review process.</a:t>
+            </a:r>
+          </a:p>
+        </p:txBody>
+      </p:sp>
+      <p:sp>
+        <p:nvSpPr>
+          <p:cNvPr id="22" name="Rectangle 21"/>
+          <p:cNvSpPr/>
+          <p:nvPr/>
+        </p:nvSpPr>
+        <p:spPr>
+          <a:xfrm>
+            <a:off x="548640" y="4754880"/>
+            <a:ext cx="1188720" cy="960120"/>
+          </a:xfrm>
+          <a:prstGeom prst="rect">
+            <a:avLst/>
+          </a:prstGeom>
+          <a:solidFill>
+            <a:srgbClr val="FFB500"/>
+          </a:solidFill>
+          <a:ln>
+            <a:noFill/>
+          </a:ln>
+          <a:effectLst/>
+        </p:spPr>
+        <p:style>
+          <a:lnRef idx="1">
+            <a:schemeClr val="accent1"/>
+          </a:lnRef>
+          <a:fillRef idx="3">
+            <a:schemeClr val="accent1"/>
+          </a:fillRef>
+          <a:effectRef idx="2">
+            <a:schemeClr val="accent1"/>
+          </a:effectRef>
+          <a:fontRef idx="minor">
+            <a:schemeClr val="lt1"/>
+          </a:fontRef>
+        </p:style>
+        <p:txBody>
+          <a:bodyPr rtlCol="0" anchor="ctr"/>
+          <a:lstStyle/>
+          <a:p>
+            <a:pPr algn="ctr"/>
+          </a:p>
+        </p:txBody>
+      </p:sp>
+      <p:sp>
+        <p:nvSpPr>
+          <p:cNvPr id="23" name="TextBox 22"/>
           <p:cNvSpPr txBox="1"/>
           <p:nvPr/>
         </p:nvSpPr>
         <p:spPr>
           <a:xfrm>
-            <a:off x="548640" y="6446520"/>
-            <a:ext cx="7315200" cy="274320"/>
+            <a:off x="548640" y="5029200"/>
+            <a:ext cx="1188720" cy="457200"/>
           </a:xfrm>
           <a:prstGeom prst="rect">
             <a:avLst/>
@@ -10603,29 +11857,73 @@
           </a:bodyPr>
           <a:lstStyle/>
           <a:p>
-            <a:pPr algn="l"/>
-            <a:r>
-              <a:rPr sz="1000" b="0">
-                <a:solidFill>
-                  <a:srgbClr val="6B6B6B"/>
-                </a:solidFill>
-                <a:latin typeface="Calibri"/>
-              </a:rPr>
-              <a:t>Fork of UPS-API/java-api-examples  •  PR #1 merged: github.com/matth4922-droid/UPS-java-api-examples/pull/1</a:t>
-            </a:r>
-          </a:p>
-        </p:txBody>
-      </p:sp>
-      <p:sp>
-        <p:nvSpPr>
-          <p:cNvPr id="28" name="TextBox 27"/>
+            <a:pPr algn="ctr"/>
+            <a:r>
+              <a:rPr sz="1600" b="1">
+                <a:solidFill>
+                  <a:srgbClr val="351C15"/>
+                </a:solidFill>
+                <a:latin typeface="Calibri"/>
+              </a:rPr>
+              <a:t>Then</a:t>
+            </a:r>
+          </a:p>
+        </p:txBody>
+      </p:sp>
+      <p:sp>
+        <p:nvSpPr>
+          <p:cNvPr id="24" name="Rectangle 23"/>
+          <p:cNvSpPr/>
+          <p:nvPr/>
+        </p:nvSpPr>
+        <p:spPr>
+          <a:xfrm>
+            <a:off x="1737360" y="4754880"/>
+            <a:ext cx="9875520" cy="960120"/>
+          </a:xfrm>
+          <a:prstGeom prst="rect">
+            <a:avLst/>
+          </a:prstGeom>
+          <a:solidFill>
+            <a:srgbClr val="F4F1EE"/>
+          </a:solidFill>
+          <a:ln>
+            <a:noFill/>
+          </a:ln>
+          <a:effectLst/>
+        </p:spPr>
+        <p:style>
+          <a:lnRef idx="1">
+            <a:schemeClr val="accent1"/>
+          </a:lnRef>
+          <a:fillRef idx="3">
+            <a:schemeClr val="accent1"/>
+          </a:fillRef>
+          <a:effectRef idx="2">
+            <a:schemeClr val="accent1"/>
+          </a:effectRef>
+          <a:fontRef idx="minor">
+            <a:schemeClr val="lt1"/>
+          </a:fontRef>
+        </p:style>
+        <p:txBody>
+          <a:bodyPr rtlCol="0" anchor="ctr"/>
+          <a:lstStyle/>
+          <a:p>
+            <a:pPr algn="ctr"/>
+          </a:p>
+        </p:txBody>
+      </p:sp>
+      <p:sp>
+        <p:nvSpPr>
+          <p:cNvPr id="25" name="TextBox 24"/>
           <p:cNvSpPr txBox="1"/>
           <p:nvPr/>
         </p:nvSpPr>
         <p:spPr>
           <a:xfrm>
-            <a:off x="11155680" y="6446520"/>
-            <a:ext cx="548640" cy="274320"/>
+            <a:off x="1920240" y="4846320"/>
+            <a:ext cx="9509760" cy="365760"/>
           </a:xfrm>
           <a:prstGeom prst="rect">
             <a:avLst/>
@@ -10638,6 +11936,111 @@
           </a:bodyPr>
           <a:lstStyle/>
           <a:p>
+            <a:pPr algn="l"/>
+            <a:r>
+              <a:rPr sz="1700" b="1">
+                <a:solidFill>
+                  <a:srgbClr val="351C15"/>
+                </a:solidFill>
+                <a:latin typeface="Calibri"/>
+              </a:rPr>
+              <a:t>Portfolio run</a:t>
+            </a:r>
+          </a:p>
+        </p:txBody>
+      </p:sp>
+      <p:sp>
+        <p:nvSpPr>
+          <p:cNvPr id="26" name="TextBox 25"/>
+          <p:cNvSpPr txBox="1"/>
+          <p:nvPr/>
+        </p:nvSpPr>
+        <p:spPr>
+          <a:xfrm>
+            <a:off x="1920240" y="5212080"/>
+            <a:ext cx="9509760" cy="502920"/>
+          </a:xfrm>
+          <a:prstGeom prst="rect">
+            <a:avLst/>
+          </a:prstGeom>
+          <a:noFill/>
+        </p:spPr>
+        <p:txBody>
+          <a:bodyPr wrap="square">
+            <a:spAutoFit/>
+          </a:bodyPr>
+          <a:lstStyle/>
+          <a:p>
+            <a:pPr algn="l"/>
+            <a:r>
+              <a:rPr sz="1300" b="0">
+                <a:solidFill>
+                  <a:srgbClr val="1F1F1F"/>
+                </a:solidFill>
+                <a:latin typeface="Calibri"/>
+              </a:rPr>
+              <a:t>Inventory Spring 2.x / Java 8 services; Devin runs the upgrade in parallel, engineers review, product-security gets the evidence pack.</a:t>
+            </a:r>
+          </a:p>
+        </p:txBody>
+      </p:sp>
+      <p:sp>
+        <p:nvSpPr>
+          <p:cNvPr id="27" name="TextBox 26"/>
+          <p:cNvSpPr txBox="1"/>
+          <p:nvPr/>
+        </p:nvSpPr>
+        <p:spPr>
+          <a:xfrm>
+            <a:off x="548640" y="6446520"/>
+            <a:ext cx="7315200" cy="274320"/>
+          </a:xfrm>
+          <a:prstGeom prst="rect">
+            <a:avLst/>
+          </a:prstGeom>
+          <a:noFill/>
+        </p:spPr>
+        <p:txBody>
+          <a:bodyPr wrap="square">
+            <a:spAutoFit/>
+          </a:bodyPr>
+          <a:lstStyle/>
+          <a:p>
+            <a:pPr algn="l"/>
+            <a:r>
+              <a:rPr sz="1000" b="0">
+                <a:solidFill>
+                  <a:srgbClr val="6B6B6B"/>
+                </a:solidFill>
+                <a:latin typeface="Calibri"/>
+              </a:rPr>
+              <a:t>Fork of UPS-API/java-api-examples  •  PR #1 merged: github.com/matth4922-droid/UPS-java-api-examples/pull/1</a:t>
+            </a:r>
+          </a:p>
+        </p:txBody>
+      </p:sp>
+      <p:sp>
+        <p:nvSpPr>
+          <p:cNvPr id="28" name="TextBox 27"/>
+          <p:cNvSpPr txBox="1"/>
+          <p:nvPr/>
+        </p:nvSpPr>
+        <p:spPr>
+          <a:xfrm>
+            <a:off x="11155680" y="6446520"/>
+            <a:ext cx="548640" cy="274320"/>
+          </a:xfrm>
+          <a:prstGeom prst="rect">
+            <a:avLst/>
+          </a:prstGeom>
+          <a:noFill/>
+        </p:spPr>
+        <p:txBody>
+          <a:bodyPr wrap="square">
+            <a:spAutoFit/>
+          </a:bodyPr>
+          <a:lstStyle/>
+          <a:p>
             <a:pPr algn="r"/>
             <a:r>
               <a:rPr sz="1000" b="0">
@@ -10646,7 +12049,7 @@
                 </a:solidFill>
                 <a:latin typeface="Calibri"/>
               </a:rPr>
-              <a:t>8</a:t>
+              <a:t>9</a:t>
             </a:r>
           </a:p>
         </p:txBody>

</xml_diff>

<commit_message>
docs: add UPS cost and revenue outcomes ROI slide
Co-Authored-By: Devin AI <158243242+devin-ai-integration[bot]@users.noreply.github.com>
</commit_message>
<xml_diff>
--- a/demo-materials/UPS-Devin-Summary-and-ROI.pptx
+++ b/demo-materials/UPS-Devin-Summary-and-ROI.pptx
@@ -16,6 +16,7 @@
     <p:sldId id="264" r:id="rId15"/>
     <p:sldId id="265" r:id="rId16"/>
     <p:sldId id="266" r:id="rId17"/>
+    <p:sldId id="267" r:id="rId18"/>
   </p:sldIdLst>
   <p:sldSz cx="12191695" cy="6858000" type="screen4x3"/>
   <p:notesSz cx="6858000" cy="9144000"/>
@@ -4876,7 +4877,7 @@
                 </a:solidFill>
                 <a:latin typeface="Calibri"/>
               </a:rPr>
-              <a:t>Next steps</a:t>
+              <a:t>ROI — UPS cost and revenue outcomes</a:t>
             </a:r>
           </a:p>
         </p:txBody>
@@ -4911,7 +4912,7 @@
                 </a:solidFill>
                 <a:latin typeface="Calibri"/>
               </a:rPr>
-              <a:t>From one proven module to a portfolio program</a:t>
+              <a:t>Cost is the proven pile of cash; revenue quality is why the AI program exists. Both depend on current APIs.</a:t>
             </a:r>
           </a:p>
         </p:txBody>
@@ -4953,14 +4954,875 @@
       </p:sp>
       <p:sp>
         <p:nvSpPr>
-          <p:cNvPr id="7" name="Rectangle 6"/>
+          <p:cNvPr id="7" name="TextBox 6"/>
+          <p:cNvSpPr txBox="1"/>
+          <p:nvPr/>
+        </p:nvSpPr>
+        <p:spPr>
+          <a:xfrm>
+            <a:off x="548640" y="1325880"/>
+            <a:ext cx="5486400" cy="365760"/>
+          </a:xfrm>
+          <a:prstGeom prst="rect">
+            <a:avLst/>
+          </a:prstGeom>
+          <a:noFill/>
+        </p:spPr>
+        <p:txBody>
+          <a:bodyPr wrap="square">
+            <a:spAutoFit/>
+          </a:bodyPr>
+          <a:lstStyle/>
+          <a:p>
+            <a:pPr algn="l"/>
+            <a:r>
+              <a:rPr sz="1600" b="1">
+                <a:solidFill>
+                  <a:srgbClr val="351C15"/>
+                </a:solidFill>
+                <a:latin typeface="Calibri"/>
+              </a:rPr>
+              <a:t>Cost — already quantified by UPS</a:t>
+            </a:r>
+          </a:p>
+        </p:txBody>
+      </p:sp>
+      <p:sp>
+        <p:nvSpPr>
+          <p:cNvPr id="8" name="TextBox 7"/>
+          <p:cNvSpPr txBox="1"/>
+          <p:nvPr/>
+        </p:nvSpPr>
+        <p:spPr>
+          <a:xfrm>
+            <a:off x="548640" y="1737360"/>
+            <a:ext cx="5577840" cy="2194560"/>
+          </a:xfrm>
+          <a:prstGeom prst="rect">
+            <a:avLst/>
+          </a:prstGeom>
+          <a:noFill/>
+        </p:spPr>
+        <p:txBody>
+          <a:bodyPr wrap="square">
+            <a:spAutoFit/>
+          </a:bodyPr>
+          <a:lstStyle/>
+          <a:p>
+            <a:pPr>
+              <a:spcAft>
+                <a:spcPts val="600"/>
+              </a:spcAft>
+            </a:pPr>
+            <a:r>
+              <a:rPr b="1" sz="1200">
+                <a:solidFill>
+                  <a:srgbClr val="351C15"/>
+                </a:solidFill>
+                <a:latin typeface="Calibri"/>
+              </a:rPr>
+              <a:t>■  ~$3.5B</a:t>
+            </a:r>
+            <a:r>
+              <a:rPr sz="1200">
+                <a:solidFill>
+                  <a:srgbClr val="1F1F1F"/>
+                </a:solidFill>
+                <a:latin typeface="Calibri"/>
+              </a:rPr>
+              <a:t>  Network Reconfiguration + Efficiency Reimagined savings in 2025.</a:t>
+            </a:r>
+          </a:p>
+          <a:p>
+            <a:pPr>
+              <a:spcAft>
+                <a:spcPts val="600"/>
+              </a:spcAft>
+            </a:pPr>
+            <a:r>
+              <a:rPr b="1" sz="1200">
+                <a:solidFill>
+                  <a:srgbClr val="351C15"/>
+                </a:solidFill>
+                <a:latin typeface="Calibri"/>
+              </a:rPr>
+              <a:t>■  ~$4.5B</a:t>
+            </a:r>
+            <a:r>
+              <a:rPr sz="1200">
+                <a:solidFill>
+                  <a:srgbClr val="1F1F1F"/>
+                </a:solidFill>
+                <a:latin typeface="Calibri"/>
+              </a:rPr>
+              <a:t>  expense removed via the Amazon glide-down (~2M pieces/day of low-yield volume out).</a:t>
+            </a:r>
+          </a:p>
+          <a:p>
+            <a:pPr>
+              <a:spcAft>
+                <a:spcPts val="600"/>
+              </a:spcAft>
+            </a:pPr>
+            <a:r>
+              <a:rPr b="1" sz="1200">
+                <a:solidFill>
+                  <a:srgbClr val="351C15"/>
+                </a:solidFill>
+                <a:latin typeface="Calibri"/>
+              </a:rPr>
+              <a:t>■  ~$3B</a:t>
+            </a:r>
+            <a:r>
+              <a:rPr sz="1200">
+                <a:solidFill>
+                  <a:srgbClr val="1F1F1F"/>
+                </a:solidFill>
+                <a:latin typeface="Calibri"/>
+              </a:rPr>
+              <a:t>  program benefits targeted for FY26; ~$1.2B booked in 1H26.</a:t>
+            </a:r>
+          </a:p>
+          <a:p>
+            <a:pPr>
+              <a:spcAft>
+                <a:spcPts val="600"/>
+              </a:spcAft>
+            </a:pPr>
+            <a:r>
+              <a:rPr b="1" sz="1200">
+                <a:solidFill>
+                  <a:srgbClr val="351C15"/>
+                </a:solidFill>
+                <a:latin typeface="Calibri"/>
+              </a:rPr>
+              <a:t>■  28% cheaper/piece</a:t>
+            </a:r>
+            <a:r>
+              <a:rPr sz="1200">
+                <a:solidFill>
+                  <a:srgbClr val="1F1F1F"/>
+                </a:solidFill>
+                <a:latin typeface="Calibri"/>
+              </a:rPr>
+              <a:t>  in automated buildings; automation at ~68.5% of U.S. volume; RFID removes hundreds of millions of manual scans/yr.</a:t>
+            </a:r>
+          </a:p>
+        </p:txBody>
+      </p:sp>
+      <p:sp>
+        <p:nvSpPr>
+          <p:cNvPr id="9" name="TextBox 8"/>
+          <p:cNvSpPr txBox="1"/>
+          <p:nvPr/>
+        </p:nvSpPr>
+        <p:spPr>
+          <a:xfrm>
+            <a:off x="6309360" y="1325880"/>
+            <a:ext cx="5486400" cy="365760"/>
+          </a:xfrm>
+          <a:prstGeom prst="rect">
+            <a:avLst/>
+          </a:prstGeom>
+          <a:noFill/>
+        </p:spPr>
+        <p:txBody>
+          <a:bodyPr wrap="square">
+            <a:spAutoFit/>
+          </a:bodyPr>
+          <a:lstStyle/>
+          <a:p>
+            <a:pPr algn="l"/>
+            <a:r>
+              <a:rPr sz="1600" b="1">
+                <a:solidFill>
+                  <a:srgbClr val="351C15"/>
+                </a:solidFill>
+                <a:latin typeface="Calibri"/>
+              </a:rPr>
+              <a:t>Revenue — better mix after the reset</a:t>
+            </a:r>
+          </a:p>
+        </p:txBody>
+      </p:sp>
+      <p:sp>
+        <p:nvSpPr>
+          <p:cNvPr id="10" name="TextBox 9"/>
+          <p:cNvSpPr txBox="1"/>
+          <p:nvPr/>
+        </p:nvSpPr>
+        <p:spPr>
+          <a:xfrm>
+            <a:off x="6309360" y="1737360"/>
+            <a:ext cx="5394960" cy="2194560"/>
+          </a:xfrm>
+          <a:prstGeom prst="rect">
+            <a:avLst/>
+          </a:prstGeom>
+          <a:noFill/>
+        </p:spPr>
+        <p:txBody>
+          <a:bodyPr wrap="square">
+            <a:spAutoFit/>
+          </a:bodyPr>
+          <a:lstStyle/>
+          <a:p>
+            <a:pPr>
+              <a:spcAft>
+                <a:spcPts val="600"/>
+              </a:spcAft>
+            </a:pPr>
+            <a:r>
+              <a:rPr b="1" sz="1200">
+                <a:solidFill>
+                  <a:srgbClr val="351C15"/>
+                </a:solidFill>
+                <a:latin typeface="Calibri"/>
+              </a:rPr>
+              <a:t>■  ~$91.2B</a:t>
+            </a:r>
+            <a:r>
+              <a:rPr sz="1200">
+                <a:solidFill>
+                  <a:srgbClr val="1F1F1F"/>
+                </a:solidFill>
+                <a:latin typeface="Calibri"/>
+              </a:rPr>
+              <a:t>  FY26 revenue guidance, raised from ~$89.7B; adj. operating profit ~$8.65B.</a:t>
+            </a:r>
+          </a:p>
+          <a:p>
+            <a:pPr>
+              <a:spcAft>
+                <a:spcPts val="600"/>
+              </a:spcAft>
+            </a:pPr>
+            <a:r>
+              <a:rPr b="1" sz="1200">
+                <a:solidFill>
+                  <a:srgbClr val="351C15"/>
+                </a:solidFill>
+                <a:latin typeface="Calibri"/>
+              </a:rPr>
+              <a:t>■  $22.8B, +7.6% YoY</a:t>
+            </a:r>
+            <a:r>
+              <a:rPr sz="1200">
+                <a:solidFill>
+                  <a:srgbClr val="1F1F1F"/>
+                </a:solidFill>
+                <a:latin typeface="Calibri"/>
+              </a:rPr>
+              <a:t>  Q2 2026 revenue after a planned volume cut; U.S. Domestic adj. OP +20%+.</a:t>
+            </a:r>
+          </a:p>
+          <a:p>
+            <a:pPr>
+              <a:spcAft>
+                <a:spcPts val="600"/>
+              </a:spcAft>
+            </a:pPr>
+            <a:r>
+              <a:rPr b="1" sz="1200">
+                <a:solidFill>
+                  <a:srgbClr val="351C15"/>
+                </a:solidFill>
+                <a:latin typeface="Calibri"/>
+              </a:rPr>
+              <a:t>■  Mix</a:t>
+            </a:r>
+            <a:r>
+              <a:rPr sz="1200">
+                <a:solidFill>
+                  <a:srgbClr val="1F1F1F"/>
+                </a:solidFill>
+                <a:latin typeface="Calibri"/>
+              </a:rPr>
+              <a:t>  SMB 34.5% of U.S. volume (+250 bps); healthcare logistics &gt;$3B/qtr; DAP &gt;$1.4B, B2B DAP +34%.</a:t>
+            </a:r>
+          </a:p>
+          <a:p>
+            <a:pPr>
+              <a:spcAft>
+                <a:spcPts val="600"/>
+              </a:spcAft>
+            </a:pPr>
+            <a:r>
+              <a:rPr b="1" sz="1200">
+                <a:solidFill>
+                  <a:srgbClr val="351C15"/>
+                </a:solidFill>
+                <a:latin typeface="Calibri"/>
+              </a:rPr>
+              <a:t>■  Stickiness</a:t>
+            </a:r>
+            <a:r>
+              <a:rPr sz="1200">
+                <a:solidFill>
+                  <a:srgbClr val="1F1F1F"/>
+                </a:solidFill>
+                <a:latin typeface="Calibri"/>
+              </a:rPr>
+              <a:t>  Control towers, RFID visibility, Happy Returns and AI brokerage keep SMB / healthcare / industrial shippers from dual-sourcing lanes.</a:t>
+            </a:r>
+          </a:p>
+        </p:txBody>
+      </p:sp>
+      <p:graphicFrame>
+        <p:nvGraphicFramePr>
+          <p:cNvPr id="11" name="Table 10"/>
+          <p:cNvGraphicFramePr>
+            <a:graphicFrameLocks noGrp="1"/>
+          </p:cNvGraphicFramePr>
+          <p:nvPr/>
+        </p:nvGraphicFramePr>
+        <p:xfrm>
+          <a:off x="548640" y="3840480"/>
+          <a:ext cx="11155680" cy="1316736"/>
+        </p:xfrm>
+        <a:graphic>
+          <a:graphicData uri="http://schemas.openxmlformats.org/drawingml/2006/table">
+            <a:tbl>
+              <a:tblPr firstRow="1" bandRow="1">
+                <a:tableStyleId>{5C22544A-7EE6-4342-B048-85BDC9FD1C3A}</a:tableStyleId>
+              </a:tblPr>
+              <a:tblGrid>
+                <a:gridCol w="4572000"/>
+                <a:gridCol w="3657600"/>
+                <a:gridCol w="2926080"/>
+              </a:tblGrid>
+              <a:tr h="329184">
+                <a:tc>
+                  <a:txBody>
+                    <a:bodyPr wrap="square"/>
+                    <a:lstStyle/>
+                    <a:p>
+                      <a:r>
+                        <a:rPr sz="1100" b="1">
+                          <a:solidFill>
+                            <a:srgbClr val="FFFFFF"/>
+                          </a:solidFill>
+                          <a:latin typeface="Calibri"/>
+                        </a:rPr>
+                        <a:t>June 2026 AI initiative</a:t>
+                      </a:r>
+                    </a:p>
+                  </a:txBody>
+                  <a:tcPr marL="91440" marR="91440" marT="36576" marB="36576">
+                    <a:solidFill>
+                      <a:srgbClr val="351C15"/>
+                    </a:solidFill>
+                  </a:tcPr>
+                </a:tc>
+                <a:tc>
+                  <a:txBody>
+                    <a:bodyPr wrap="square"/>
+                    <a:lstStyle/>
+                    <a:p>
+                      <a:r>
+                        <a:rPr sz="1100" b="1">
+                          <a:solidFill>
+                            <a:srgbClr val="FFFFFF"/>
+                          </a:solidFill>
+                          <a:latin typeface="Calibri"/>
+                        </a:rPr>
+                        <a:t>If it works</a:t>
+                      </a:r>
+                    </a:p>
+                  </a:txBody>
+                  <a:tcPr marL="91440" marR="91440" marT="36576" marB="36576">
+                    <a:solidFill>
+                      <a:srgbClr val="351C15"/>
+                    </a:solidFill>
+                  </a:tcPr>
+                </a:tc>
+                <a:tc>
+                  <a:txBody>
+                    <a:bodyPr wrap="square"/>
+                    <a:lstStyle/>
+                    <a:p>
+                      <a:r>
+                        <a:rPr sz="1100" b="1">
+                          <a:solidFill>
+                            <a:srgbClr val="FFFFFF"/>
+                          </a:solidFill>
+                          <a:latin typeface="Calibri"/>
+                        </a:rPr>
+                        <a:t>P&amp;L effect</a:t>
+                      </a:r>
+                    </a:p>
+                  </a:txBody>
+                  <a:tcPr marL="91440" marR="91440" marT="36576" marB="36576">
+                    <a:solidFill>
+                      <a:srgbClr val="351C15"/>
+                    </a:solidFill>
+                  </a:tcPr>
+                </a:tc>
+              </a:tr>
+              <a:tr h="329184">
+                <a:tc>
+                  <a:txBody>
+                    <a:bodyPr wrap="square"/>
+                    <a:lstStyle/>
+                    <a:p>
+                      <a:r>
+                        <a:rPr sz="1100" b="0">
+                          <a:solidFill>
+                            <a:srgbClr val="1F1F1F"/>
+                          </a:solidFill>
+                          <a:latin typeface="Calibri"/>
+                        </a:rPr>
+                        <a:t>Tracking + AI assistants on &gt;98% of CS requests by YE26</a:t>
+                      </a:r>
+                    </a:p>
+                  </a:txBody>
+                  <a:tcPr marL="91440" marR="91440" marT="36576" marB="36576">
+                    <a:solidFill>
+                      <a:srgbClr val="F4F1EE"/>
+                    </a:solidFill>
+                  </a:tcPr>
+                </a:tc>
+                <a:tc>
+                  <a:txBody>
+                    <a:bodyPr wrap="square"/>
+                    <a:lstStyle/>
+                    <a:p>
+                      <a:r>
+                        <a:rPr sz="1100" b="0">
+                          <a:solidFill>
+                            <a:srgbClr val="1F1F1F"/>
+                          </a:solidFill>
+                          <a:latin typeface="Calibri"/>
+                        </a:rPr>
+                        <a:t>Fewer calls, faster claims</a:t>
+                      </a:r>
+                    </a:p>
+                  </a:txBody>
+                  <a:tcPr marL="91440" marR="91440" marT="36576" marB="36576">
+                    <a:solidFill>
+                      <a:srgbClr val="F4F1EE"/>
+                    </a:solidFill>
+                  </a:tcPr>
+                </a:tc>
+                <a:tc>
+                  <a:txBody>
+                    <a:bodyPr wrap="square"/>
+                    <a:lstStyle/>
+                    <a:p>
+                      <a:r>
+                        <a:rPr sz="1100" b="0">
+                          <a:solidFill>
+                            <a:srgbClr val="1F1F1F"/>
+                          </a:solidFill>
+                          <a:latin typeface="Calibri"/>
+                        </a:rPr>
+                        <a:t>Cost first, then retention</a:t>
+                      </a:r>
+                    </a:p>
+                  </a:txBody>
+                  <a:tcPr marL="91440" marR="91440" marT="36576" marB="36576">
+                    <a:solidFill>
+                      <a:srgbClr val="F4F1EE"/>
+                    </a:solidFill>
+                  </a:tcPr>
+                </a:tc>
+              </a:tr>
+              <a:tr h="329184">
+                <a:tc>
+                  <a:txBody>
+                    <a:bodyPr wrap="square"/>
+                    <a:lstStyle/>
+                    <a:p>
+                      <a:r>
+                        <a:rPr sz="1100" b="0">
+                          <a:solidFill>
+                            <a:srgbClr val="1F1F1F"/>
+                          </a:solidFill>
+                          <a:latin typeface="Calibri"/>
+                        </a:rPr>
+                        <a:t>RFID + AI package-level tracking, digital twin (10-min refresh)</a:t>
+                      </a:r>
+                    </a:p>
+                  </a:txBody>
+                  <a:tcPr marL="91440" marR="91440" marT="36576" marB="36576">
+                    <a:solidFill>
+                      <a:srgbClr val="FFFFFF"/>
+                    </a:solidFill>
+                  </a:tcPr>
+                </a:tc>
+                <a:tc>
+                  <a:txBody>
+                    <a:bodyPr wrap="square"/>
+                    <a:lstStyle/>
+                    <a:p>
+                      <a:r>
+                        <a:rPr sz="1100" b="0">
+                          <a:solidFill>
+                            <a:srgbClr val="1F1F1F"/>
+                          </a:solidFill>
+                          <a:latin typeface="Calibri"/>
+                        </a:rPr>
+                        <a:t>Fewer manual scans, self-healing network</a:t>
+                      </a:r>
+                    </a:p>
+                  </a:txBody>
+                  <a:tcPr marL="91440" marR="91440" marT="36576" marB="36576">
+                    <a:solidFill>
+                      <a:srgbClr val="FFFFFF"/>
+                    </a:solidFill>
+                  </a:tcPr>
+                </a:tc>
+                <a:tc>
+                  <a:txBody>
+                    <a:bodyPr wrap="square"/>
+                    <a:lstStyle/>
+                    <a:p>
+                      <a:r>
+                        <a:rPr sz="1100" b="0">
+                          <a:solidFill>
+                            <a:srgbClr val="1F1F1F"/>
+                          </a:solidFill>
+                          <a:latin typeface="Calibri"/>
+                        </a:rPr>
+                        <a:t>Cost (labor, idle assets)</a:t>
+                      </a:r>
+                    </a:p>
+                  </a:txBody>
+                  <a:tcPr marL="91440" marR="91440" marT="36576" marB="36576">
+                    <a:solidFill>
+                      <a:srgbClr val="FFFFFF"/>
+                    </a:solidFill>
+                  </a:tcPr>
+                </a:tc>
+              </a:tr>
+              <a:tr h="329184">
+                <a:tc>
+                  <a:txBody>
+                    <a:bodyPr wrap="square"/>
+                    <a:lstStyle/>
+                    <a:p>
+                      <a:r>
+                        <a:rPr sz="1100" b="0">
+                          <a:solidFill>
+                            <a:srgbClr val="1F1F1F"/>
+                          </a:solidFill>
+                          <a:latin typeface="Calibri"/>
+                        </a:rPr>
+                        <a:t>Agentic control towers; AI brokerage / customs (97% first-day entry)</a:t>
+                      </a:r>
+                    </a:p>
+                  </a:txBody>
+                  <a:tcPr marL="91440" marR="91440" marT="36576" marB="36576">
+                    <a:solidFill>
+                      <a:srgbClr val="F4F1EE"/>
+                    </a:solidFill>
+                  </a:tcPr>
+                </a:tc>
+                <a:tc>
+                  <a:txBody>
+                    <a:bodyPr wrap="square"/>
+                    <a:lstStyle/>
+                    <a:p>
+                      <a:r>
+                        <a:rPr sz="1100" b="0">
+                          <a:solidFill>
+                            <a:srgbClr val="1F1F1F"/>
+                          </a:solidFill>
+                          <a:latin typeface="Calibri"/>
+                        </a:rPr>
+                        <a:t>Exception mgmt for big shippers; predictable landed cost</a:t>
+                      </a:r>
+                    </a:p>
+                  </a:txBody>
+                  <a:tcPr marL="91440" marR="91440" marT="36576" marB="36576">
+                    <a:solidFill>
+                      <a:srgbClr val="F4F1EE"/>
+                    </a:solidFill>
+                  </a:tcPr>
+                </a:tc>
+                <a:tc>
+                  <a:txBody>
+                    <a:bodyPr wrap="square"/>
+                    <a:lstStyle/>
+                    <a:p>
+                      <a:r>
+                        <a:rPr sz="1100" b="0">
+                          <a:solidFill>
+                            <a:srgbClr val="1F1F1F"/>
+                          </a:solidFill>
+                          <a:latin typeface="Calibri"/>
+                        </a:rPr>
+                        <a:t>Revenue (enterprise, cross-border, SMB)</a:t>
+                      </a:r>
+                    </a:p>
+                  </a:txBody>
+                  <a:tcPr marL="91440" marR="91440" marT="36576" marB="36576">
+                    <a:solidFill>
+                      <a:srgbClr val="F4F1EE"/>
+                    </a:solidFill>
+                  </a:tcPr>
+                </a:tc>
+              </a:tr>
+            </a:tbl>
+          </a:graphicData>
+        </a:graphic>
+      </p:graphicFrame>
+      <p:sp>
+        <p:nvSpPr>
+          <p:cNvPr id="12" name="Rectangle 11"/>
           <p:cNvSpPr/>
           <p:nvPr/>
         </p:nvSpPr>
         <p:spPr>
           <a:xfrm>
-            <a:off x="548640" y="1463040"/>
-            <a:ext cx="1188720" cy="960120"/>
+            <a:off x="548640" y="5257800"/>
+            <a:ext cx="11155680" cy="777240"/>
+          </a:xfrm>
+          <a:prstGeom prst="rect">
+            <a:avLst/>
+          </a:prstGeom>
+          <a:solidFill>
+            <a:srgbClr val="351C15"/>
+          </a:solidFill>
+          <a:ln>
+            <a:noFill/>
+          </a:ln>
+          <a:effectLst/>
+        </p:spPr>
+        <p:style>
+          <a:lnRef idx="1">
+            <a:schemeClr val="accent1"/>
+          </a:lnRef>
+          <a:fillRef idx="3">
+            <a:schemeClr val="accent1"/>
+          </a:fillRef>
+          <a:effectRef idx="2">
+            <a:schemeClr val="accent1"/>
+          </a:effectRef>
+          <a:fontRef idx="minor">
+            <a:schemeClr val="lt1"/>
+          </a:fontRef>
+        </p:style>
+        <p:txBody>
+          <a:bodyPr rtlCol="0" anchor="ctr"/>
+          <a:lstStyle/>
+          <a:p>
+            <a:pPr algn="ctr"/>
+          </a:p>
+        </p:txBody>
+      </p:sp>
+      <p:sp>
+        <p:nvSpPr>
+          <p:cNvPr id="13" name="TextBox 12"/>
+          <p:cNvSpPr txBox="1"/>
+          <p:nvPr/>
+        </p:nvSpPr>
+        <p:spPr>
+          <a:xfrm>
+            <a:off x="731520" y="5321808"/>
+            <a:ext cx="10789920" cy="685800"/>
+          </a:xfrm>
+          <a:prstGeom prst="rect">
+            <a:avLst/>
+          </a:prstGeom>
+          <a:noFill/>
+        </p:spPr>
+        <p:txBody>
+          <a:bodyPr wrap="square">
+            <a:spAutoFit/>
+          </a:bodyPr>
+          <a:lstStyle/>
+          <a:p>
+            <a:pPr algn="l"/>
+            <a:r>
+              <a:rPr sz="1100" b="1">
+                <a:solidFill>
+                  <a:srgbClr val="FFFFFF"/>
+                </a:solidFill>
+                <a:latin typeface="Calibri"/>
+              </a:rPr>
+              <a:t>The June AI program does not replace the $3B–$4.5B cost takeout; it converts it into higher-quality revenue and a network that still works when volume returns. That only holds if Track, Ship, Rate, brokerage and the digital twin stay current — a Java 8 / Boot 2.7 estate under those APIs is a business problem, not a tidy-up.</a:t>
+            </a:r>
+          </a:p>
+        </p:txBody>
+      </p:sp>
+      <p:sp>
+        <p:nvSpPr>
+          <p:cNvPr id="14" name="TextBox 13"/>
+          <p:cNvSpPr txBox="1"/>
+          <p:nvPr/>
+        </p:nvSpPr>
+        <p:spPr>
+          <a:xfrm>
+            <a:off x="548640" y="6053328"/>
+            <a:ext cx="10972800" cy="365760"/>
+          </a:xfrm>
+          <a:prstGeom prst="rect">
+            <a:avLst/>
+          </a:prstGeom>
+          <a:noFill/>
+        </p:spPr>
+        <p:txBody>
+          <a:bodyPr wrap="square">
+            <a:spAutoFit/>
+          </a:bodyPr>
+          <a:lstStyle/>
+          <a:p>
+            <a:pPr algn="l"/>
+            <a:r>
+              <a:rPr sz="900" b="0">
+                <a:solidFill>
+                  <a:srgbClr val="6B6B6B"/>
+                </a:solidFill>
+                <a:latin typeface="Calibri"/>
+              </a:rPr>
+              <a:t>Sources: UPS June 18, 2026 AI release; UPS Q2 2026 earnings / FY26 guidance. Savings are booked by UPS to network redesign and mix — not attributed to AI.</a:t>
+            </a:r>
+          </a:p>
+        </p:txBody>
+      </p:sp>
+      <p:sp>
+        <p:nvSpPr>
+          <p:cNvPr id="15" name="TextBox 14"/>
+          <p:cNvSpPr txBox="1"/>
+          <p:nvPr/>
+        </p:nvSpPr>
+        <p:spPr>
+          <a:xfrm>
+            <a:off x="548640" y="6446520"/>
+            <a:ext cx="7315200" cy="274320"/>
+          </a:xfrm>
+          <a:prstGeom prst="rect">
+            <a:avLst/>
+          </a:prstGeom>
+          <a:noFill/>
+        </p:spPr>
+        <p:txBody>
+          <a:bodyPr wrap="square">
+            <a:spAutoFit/>
+          </a:bodyPr>
+          <a:lstStyle/>
+          <a:p>
+            <a:pPr algn="l"/>
+            <a:r>
+              <a:rPr sz="1000" b="0">
+                <a:solidFill>
+                  <a:srgbClr val="6B6B6B"/>
+                </a:solidFill>
+                <a:latin typeface="Calibri"/>
+              </a:rPr>
+              <a:t>Fork of UPS-API/java-api-examples  •  PR #1 merged: github.com/matth4922-droid/UPS-java-api-examples/pull/1</a:t>
+            </a:r>
+          </a:p>
+        </p:txBody>
+      </p:sp>
+      <p:sp>
+        <p:nvSpPr>
+          <p:cNvPr id="16" name="TextBox 15"/>
+          <p:cNvSpPr txBox="1"/>
+          <p:nvPr/>
+        </p:nvSpPr>
+        <p:spPr>
+          <a:xfrm>
+            <a:off x="11155680" y="6446520"/>
+            <a:ext cx="548640" cy="274320"/>
+          </a:xfrm>
+          <a:prstGeom prst="rect">
+            <a:avLst/>
+          </a:prstGeom>
+          <a:noFill/>
+        </p:spPr>
+        <p:txBody>
+          <a:bodyPr wrap="square">
+            <a:spAutoFit/>
+          </a:bodyPr>
+          <a:lstStyle/>
+          <a:p>
+            <a:pPr algn="r"/>
+            <a:r>
+              <a:rPr sz="1000" b="0">
+                <a:solidFill>
+                  <a:srgbClr val="6B6B6B"/>
+                </a:solidFill>
+                <a:latin typeface="Calibri"/>
+              </a:rPr>
+              <a:t>11</a:t>
+            </a:r>
+          </a:p>
+        </p:txBody>
+      </p:sp>
+    </p:spTree>
+  </p:cSld>
+  <p:clrMapOvr>
+    <a:masterClrMapping/>
+  </p:clrMapOvr>
+</p:sld>
+</file>
+
+<file path=ppt/slides/slide12.xml><?xml version="1.0" encoding="utf-8"?>
+<p:sld xmlns:a="http://schemas.openxmlformats.org/drawingml/2006/main" xmlns:p="http://schemas.openxmlformats.org/presentationml/2006/main" xmlns:r="http://schemas.openxmlformats.org/officeDocument/2006/relationships">
+  <p:cSld>
+    <p:spTree>
+      <p:nvGrpSpPr>
+        <p:cNvPr id="1" name=""/>
+        <p:cNvGrpSpPr/>
+        <p:nvPr/>
+      </p:nvGrpSpPr>
+      <p:grpSpPr/>
+      <p:sp>
+        <p:nvSpPr>
+          <p:cNvPr id="2" name="Rectangle 1"/>
+          <p:cNvSpPr/>
+          <p:nvPr/>
+        </p:nvSpPr>
+        <p:spPr>
+          <a:xfrm>
+            <a:off x="0" y="0"/>
+            <a:ext cx="12191695" cy="1051560"/>
+          </a:xfrm>
+          <a:prstGeom prst="rect">
+            <a:avLst/>
+          </a:prstGeom>
+          <a:solidFill>
+            <a:srgbClr val="351C15"/>
+          </a:solidFill>
+          <a:ln>
+            <a:noFill/>
+          </a:ln>
+          <a:effectLst/>
+        </p:spPr>
+        <p:style>
+          <a:lnRef idx="1">
+            <a:schemeClr val="accent1"/>
+          </a:lnRef>
+          <a:fillRef idx="3">
+            <a:schemeClr val="accent1"/>
+          </a:fillRef>
+          <a:effectRef idx="2">
+            <a:schemeClr val="accent1"/>
+          </a:effectRef>
+          <a:fontRef idx="minor">
+            <a:schemeClr val="lt1"/>
+          </a:fontRef>
+        </p:style>
+        <p:txBody>
+          <a:bodyPr rtlCol="0" anchor="ctr"/>
+          <a:lstStyle/>
+          <a:p>
+            <a:pPr algn="ctr"/>
+          </a:p>
+        </p:txBody>
+      </p:sp>
+      <p:sp>
+        <p:nvSpPr>
+          <p:cNvPr id="3" name="Rectangle 2"/>
+          <p:cNvSpPr/>
+          <p:nvPr/>
+        </p:nvSpPr>
+        <p:spPr>
+          <a:xfrm>
+            <a:off x="0" y="1051560"/>
+            <a:ext cx="12191695" cy="73152"/>
           </a:xfrm>
           <a:prstGeom prst="rect">
             <a:avLst/>
@@ -4997,6 +5859,155 @@
       </p:sp>
       <p:sp>
         <p:nvSpPr>
+          <p:cNvPr id="4" name="TextBox 3"/>
+          <p:cNvSpPr txBox="1"/>
+          <p:nvPr/>
+        </p:nvSpPr>
+        <p:spPr>
+          <a:xfrm>
+            <a:off x="548640" y="201168"/>
+            <a:ext cx="10058400" cy="731520"/>
+          </a:xfrm>
+          <a:prstGeom prst="rect">
+            <a:avLst/>
+          </a:prstGeom>
+          <a:noFill/>
+        </p:spPr>
+        <p:txBody>
+          <a:bodyPr wrap="square">
+            <a:spAutoFit/>
+          </a:bodyPr>
+          <a:lstStyle/>
+          <a:p>
+            <a:pPr algn="l"/>
+            <a:r>
+              <a:rPr sz="2600" b="1">
+                <a:solidFill>
+                  <a:srgbClr val="FFFFFF"/>
+                </a:solidFill>
+                <a:latin typeface="Calibri"/>
+              </a:rPr>
+              <a:t>Next steps</a:t>
+            </a:r>
+          </a:p>
+        </p:txBody>
+      </p:sp>
+      <p:sp>
+        <p:nvSpPr>
+          <p:cNvPr id="5" name="TextBox 4"/>
+          <p:cNvSpPr txBox="1"/>
+          <p:nvPr/>
+        </p:nvSpPr>
+        <p:spPr>
+          <a:xfrm>
+            <a:off x="548640" y="658368"/>
+            <a:ext cx="10058400" cy="365760"/>
+          </a:xfrm>
+          <a:prstGeom prst="rect">
+            <a:avLst/>
+          </a:prstGeom>
+          <a:noFill/>
+        </p:spPr>
+        <p:txBody>
+          <a:bodyPr wrap="square">
+            <a:spAutoFit/>
+          </a:bodyPr>
+          <a:lstStyle/>
+          <a:p>
+            <a:pPr algn="l"/>
+            <a:r>
+              <a:rPr sz="1400" b="0">
+                <a:solidFill>
+                  <a:srgbClr val="FFB500"/>
+                </a:solidFill>
+                <a:latin typeface="Calibri"/>
+              </a:rPr>
+              <a:t>From one proven module to a portfolio program</a:t>
+            </a:r>
+          </a:p>
+        </p:txBody>
+      </p:sp>
+      <p:sp>
+        <p:nvSpPr>
+          <p:cNvPr id="6" name="TextBox 5"/>
+          <p:cNvSpPr txBox="1"/>
+          <p:nvPr/>
+        </p:nvSpPr>
+        <p:spPr>
+          <a:xfrm>
+            <a:off x="9875520" y="320040"/>
+            <a:ext cx="2103120" cy="457200"/>
+          </a:xfrm>
+          <a:prstGeom prst="rect">
+            <a:avLst/>
+          </a:prstGeom>
+          <a:noFill/>
+        </p:spPr>
+        <p:txBody>
+          <a:bodyPr wrap="square">
+            <a:spAutoFit/>
+          </a:bodyPr>
+          <a:lstStyle/>
+          <a:p>
+            <a:pPr algn="r"/>
+            <a:r>
+              <a:rPr sz="1400" b="1">
+                <a:solidFill>
+                  <a:srgbClr val="FFB500"/>
+                </a:solidFill>
+                <a:latin typeface="Calibri"/>
+              </a:rPr>
+              <a:t>Devin  ×  UPS</a:t>
+            </a:r>
+          </a:p>
+        </p:txBody>
+      </p:sp>
+      <p:sp>
+        <p:nvSpPr>
+          <p:cNvPr id="7" name="Rectangle 6"/>
+          <p:cNvSpPr/>
+          <p:nvPr/>
+        </p:nvSpPr>
+        <p:spPr>
+          <a:xfrm>
+            <a:off x="548640" y="1463040"/>
+            <a:ext cx="1188720" cy="960120"/>
+          </a:xfrm>
+          <a:prstGeom prst="rect">
+            <a:avLst/>
+          </a:prstGeom>
+          <a:solidFill>
+            <a:srgbClr val="FFB500"/>
+          </a:solidFill>
+          <a:ln>
+            <a:noFill/>
+          </a:ln>
+          <a:effectLst/>
+        </p:spPr>
+        <p:style>
+          <a:lnRef idx="1">
+            <a:schemeClr val="accent1"/>
+          </a:lnRef>
+          <a:fillRef idx="3">
+            <a:schemeClr val="accent1"/>
+          </a:fillRef>
+          <a:effectRef idx="2">
+            <a:schemeClr val="accent1"/>
+          </a:effectRef>
+          <a:fontRef idx="minor">
+            <a:schemeClr val="lt1"/>
+          </a:fontRef>
+        </p:style>
+        <p:txBody>
+          <a:bodyPr rtlCol="0" anchor="ctr"/>
+          <a:lstStyle/>
+          <a:p>
+            <a:pPr algn="ctr"/>
+          </a:p>
+        </p:txBody>
+      </p:sp>
+      <p:sp>
+        <p:nvSpPr>
           <p:cNvPr id="8" name="TextBox 7"/>
           <p:cNvSpPr txBox="1"/>
           <p:nvPr/>
@@ -5788,7 +6799,7 @@
                 </a:solidFill>
                 <a:latin typeface="Calibri"/>
               </a:rPr>
-              <a:t>11</a:t>
+              <a:t>12</a:t>
             </a:r>
           </a:p>
         </p:txBody>

</xml_diff>